<commit_message>
Add HFA DS migration scripts and align tokens with Penpot library.
Document the shared HFA DS hub, add Penpot MCP migration helpers, sync tokens.json typography with Source Sans 3, and extend prototype4 with foreground-muted tokens plus editable-text and layout fixes.

Co-authored-by: Cursor <cursoragent@cursor.com>
</commit_message>
<xml_diff>
--- a/bowtie_design_notes.pptx
+++ b/bowtie_design_notes.pptx
@@ -7,6 +7,12 @@
   <p:sldIdLst>
     <p:sldId id="256" r:id="rId2"/>
     <p:sldId id="257" r:id="rId3"/>
+    <p:sldId id="258" r:id="rId4"/>
+    <p:sldId id="259" r:id="rId5"/>
+    <p:sldId id="260" r:id="rId6"/>
+    <p:sldId id="261" r:id="rId7"/>
+    <p:sldId id="262" r:id="rId8"/>
+    <p:sldId id="263" r:id="rId9"/>
   </p:sldIdLst>
   <p:sldSz cx="12192000" cy="6858000"/>
   <p:notesSz cx="6858000" cy="9144000"/>
@@ -105,13 +111,18 @@
       </a:defRPr>
     </a:lvl9pPr>
   </p:defaultTextStyle>
+  <p:extLst>
+    <p:ext uri="{EFAFB233-063F-42B5-8137-9DF3F51BA10A}">
+      <p15:sldGuideLst xmlns:p15="http://schemas.microsoft.com/office/powerpoint/2012/main"/>
+    </p:ext>
+  </p:extLst>
 </p:presentation>
 </file>
 
 <file path=ppt/revisionInfo.xml><?xml version="1.0" encoding="utf-8"?>
 <p1510:revInfo xmlns:a="http://schemas.openxmlformats.org/drawingml/2006/main" xmlns:r="http://schemas.openxmlformats.org/officeDocument/2006/relationships" xmlns:p1510="http://schemas.microsoft.com/office/powerpoint/2015/10/main">
   <p1510:revLst>
-    <p1510:client id="{3BCA02BA-0FB2-DA4B-8BBC-CE8B401E8468}" v="5" dt="2026-07-21T08:42:23.198"/>
+    <p1510:client id="{3BCA02BA-0FB2-DA4B-8BBC-CE8B401E8468}" v="15" dt="2026-07-21T21:23:00.041"/>
   </p1510:revLst>
 </p1510:revInfo>
 </file>
@@ -121,7 +132,7 @@
   <pc:docChgLst>
     <pc:chgData name="Lars Pettersson" userId="bbe8ee3e1743ce4e" providerId="LiveId" clId="{76C9B083-C5CE-54A4-81E8-16672380D724}"/>
     <pc:docChg chg="undo custSel addSld modSld">
-      <pc:chgData name="Lars Pettersson" userId="bbe8ee3e1743ce4e" providerId="LiveId" clId="{76C9B083-C5CE-54A4-81E8-16672380D724}" dt="2026-07-21T08:42:43.766" v="108" actId="1076"/>
+      <pc:chgData name="Lars Pettersson" userId="bbe8ee3e1743ce4e" providerId="LiveId" clId="{76C9B083-C5CE-54A4-81E8-16672380D724}" dt="2026-07-21T21:24:18.875" v="545" actId="20577"/>
       <pc:docMkLst>
         <pc:docMk/>
       </pc:docMkLst>
@@ -210,6 +221,200 @@
             <ac:picMk id="4" creationId="{246BFC48-AB3C-00F5-2887-91658A85E46D}"/>
           </ac:picMkLst>
         </pc:picChg>
+      </pc:sldChg>
+      <pc:sldChg chg="addSp delSp modSp new mod">
+        <pc:chgData name="Lars Pettersson" userId="bbe8ee3e1743ce4e" providerId="LiveId" clId="{76C9B083-C5CE-54A4-81E8-16672380D724}" dt="2026-07-21T19:30:03.427" v="222" actId="20577"/>
+        <pc:sldMkLst>
+          <pc:docMk/>
+          <pc:sldMk cId="3747206509" sldId="258"/>
+        </pc:sldMkLst>
+        <pc:spChg chg="mod">
+          <ac:chgData name="Lars Pettersson" userId="bbe8ee3e1743ce4e" providerId="LiveId" clId="{76C9B083-C5CE-54A4-81E8-16672380D724}" dt="2026-07-21T19:30:03.427" v="222" actId="20577"/>
+          <ac:spMkLst>
+            <pc:docMk/>
+            <pc:sldMk cId="3747206509" sldId="258"/>
+            <ac:spMk id="2" creationId="{F3565B0E-85EC-C1F0-9D40-0C6F287C30EB}"/>
+          </ac:spMkLst>
+        </pc:spChg>
+        <pc:spChg chg="del">
+          <ac:chgData name="Lars Pettersson" userId="bbe8ee3e1743ce4e" providerId="LiveId" clId="{76C9B083-C5CE-54A4-81E8-16672380D724}" dt="2026-07-21T19:21:53.582" v="121" actId="478"/>
+          <ac:spMkLst>
+            <pc:docMk/>
+            <pc:sldMk cId="3747206509" sldId="258"/>
+            <ac:spMk id="3" creationId="{63BF095E-2ECE-6E95-0543-AB1FCB1518B2}"/>
+          </ac:spMkLst>
+        </pc:spChg>
+        <pc:picChg chg="add mod">
+          <ac:chgData name="Lars Pettersson" userId="bbe8ee3e1743ce4e" providerId="LiveId" clId="{76C9B083-C5CE-54A4-81E8-16672380D724}" dt="2026-07-21T19:22:23.562" v="200" actId="1076"/>
+          <ac:picMkLst>
+            <pc:docMk/>
+            <pc:sldMk cId="3747206509" sldId="258"/>
+            <ac:picMk id="4" creationId="{50054214-4128-FA97-4963-AE24CC8545D9}"/>
+          </ac:picMkLst>
+        </pc:picChg>
+      </pc:sldChg>
+      <pc:sldChg chg="addSp delSp modSp new mod">
+        <pc:chgData name="Lars Pettersson" userId="bbe8ee3e1743ce4e" providerId="LiveId" clId="{76C9B083-C5CE-54A4-81E8-16672380D724}" dt="2026-07-21T19:30:15.385" v="237" actId="20577"/>
+        <pc:sldMkLst>
+          <pc:docMk/>
+          <pc:sldMk cId="3679306684" sldId="259"/>
+        </pc:sldMkLst>
+        <pc:spChg chg="mod">
+          <ac:chgData name="Lars Pettersson" userId="bbe8ee3e1743ce4e" providerId="LiveId" clId="{76C9B083-C5CE-54A4-81E8-16672380D724}" dt="2026-07-21T19:30:15.385" v="237" actId="20577"/>
+          <ac:spMkLst>
+            <pc:docMk/>
+            <pc:sldMk cId="3679306684" sldId="259"/>
+            <ac:spMk id="2" creationId="{F1CECDB1-7D3A-7A83-5B7D-A007AB72549C}"/>
+          </ac:spMkLst>
+        </pc:spChg>
+        <pc:spChg chg="del">
+          <ac:chgData name="Lars Pettersson" userId="bbe8ee3e1743ce4e" providerId="LiveId" clId="{76C9B083-C5CE-54A4-81E8-16672380D724}" dt="2026-07-21T19:29:39.822" v="202"/>
+          <ac:spMkLst>
+            <pc:docMk/>
+            <pc:sldMk cId="3679306684" sldId="259"/>
+            <ac:spMk id="3" creationId="{46F1EA74-9666-44F5-4C4C-CCB403A2C265}"/>
+          </ac:spMkLst>
+        </pc:spChg>
+        <pc:picChg chg="add mod">
+          <ac:chgData name="Lars Pettersson" userId="bbe8ee3e1743ce4e" providerId="LiveId" clId="{76C9B083-C5CE-54A4-81E8-16672380D724}" dt="2026-07-21T19:29:39.822" v="202"/>
+          <ac:picMkLst>
+            <pc:docMk/>
+            <pc:sldMk cId="3679306684" sldId="259"/>
+            <ac:picMk id="4" creationId="{5D2584DA-DC7E-8B34-683C-9704D8C5F166}"/>
+          </ac:picMkLst>
+        </pc:picChg>
+      </pc:sldChg>
+      <pc:sldChg chg="addSp delSp modSp new mod">
+        <pc:chgData name="Lars Pettersson" userId="bbe8ee3e1743ce4e" providerId="LiveId" clId="{76C9B083-C5CE-54A4-81E8-16672380D724}" dt="2026-07-21T19:30:58.098" v="261" actId="20577"/>
+        <pc:sldMkLst>
+          <pc:docMk/>
+          <pc:sldMk cId="1360940721" sldId="260"/>
+        </pc:sldMkLst>
+        <pc:spChg chg="mod">
+          <ac:chgData name="Lars Pettersson" userId="bbe8ee3e1743ce4e" providerId="LiveId" clId="{76C9B083-C5CE-54A4-81E8-16672380D724}" dt="2026-07-21T19:30:58.098" v="261" actId="20577"/>
+          <ac:spMkLst>
+            <pc:docMk/>
+            <pc:sldMk cId="1360940721" sldId="260"/>
+            <ac:spMk id="2" creationId="{38491A15-B9B9-97A3-92B4-CAE77F2E2C29}"/>
+          </ac:spMkLst>
+        </pc:spChg>
+        <pc:spChg chg="del">
+          <ac:chgData name="Lars Pettersson" userId="bbe8ee3e1743ce4e" providerId="LiveId" clId="{76C9B083-C5CE-54A4-81E8-16672380D724}" dt="2026-07-21T19:30:42.103" v="244"/>
+          <ac:spMkLst>
+            <pc:docMk/>
+            <pc:sldMk cId="1360940721" sldId="260"/>
+            <ac:spMk id="3" creationId="{4667A593-5957-FF1E-B6DF-6A8C08F38635}"/>
+          </ac:spMkLst>
+        </pc:spChg>
+        <pc:picChg chg="add">
+          <ac:chgData name="Lars Pettersson" userId="bbe8ee3e1743ce4e" providerId="LiveId" clId="{76C9B083-C5CE-54A4-81E8-16672380D724}" dt="2026-07-21T19:30:39.695" v="243"/>
+          <ac:picMkLst>
+            <pc:docMk/>
+            <pc:sldMk cId="1360940721" sldId="260"/>
+            <ac:picMk id="4" creationId="{581EE6AA-536A-7C5C-B0C5-E135B6F58E85}"/>
+          </ac:picMkLst>
+        </pc:picChg>
+        <pc:picChg chg="add mod">
+          <ac:chgData name="Lars Pettersson" userId="bbe8ee3e1743ce4e" providerId="LiveId" clId="{76C9B083-C5CE-54A4-81E8-16672380D724}" dt="2026-07-21T19:30:42.103" v="244"/>
+          <ac:picMkLst>
+            <pc:docMk/>
+            <pc:sldMk cId="1360940721" sldId="260"/>
+            <ac:picMk id="5" creationId="{BEABF87E-C70D-9F6A-7E5C-93B2F011562F}"/>
+          </ac:picMkLst>
+        </pc:picChg>
+      </pc:sldChg>
+      <pc:sldChg chg="addSp delSp modSp new mod">
+        <pc:chgData name="Lars Pettersson" userId="bbe8ee3e1743ce4e" providerId="LiveId" clId="{76C9B083-C5CE-54A4-81E8-16672380D724}" dt="2026-07-21T19:56:20.799" v="309" actId="1076"/>
+        <pc:sldMkLst>
+          <pc:docMk/>
+          <pc:sldMk cId="3762900069" sldId="261"/>
+        </pc:sldMkLst>
+        <pc:spChg chg="mod">
+          <ac:chgData name="Lars Pettersson" userId="bbe8ee3e1743ce4e" providerId="LiveId" clId="{76C9B083-C5CE-54A4-81E8-16672380D724}" dt="2026-07-21T19:47:32.945" v="301" actId="20577"/>
+          <ac:spMkLst>
+            <pc:docMk/>
+            <pc:sldMk cId="3762900069" sldId="261"/>
+            <ac:spMk id="2" creationId="{A10DAAD5-D6ED-BFCC-B880-C576B6937BC3}"/>
+          </ac:spMkLst>
+        </pc:spChg>
+        <pc:spChg chg="del">
+          <ac:chgData name="Lars Pettersson" userId="bbe8ee3e1743ce4e" providerId="LiveId" clId="{76C9B083-C5CE-54A4-81E8-16672380D724}" dt="2026-07-21T19:47:34.579" v="302"/>
+          <ac:spMkLst>
+            <pc:docMk/>
+            <pc:sldMk cId="3762900069" sldId="261"/>
+            <ac:spMk id="3" creationId="{1B873FFD-A2B5-3F7A-8C7E-4D091B179FD4}"/>
+          </ac:spMkLst>
+        </pc:spChg>
+        <pc:picChg chg="add mod">
+          <ac:chgData name="Lars Pettersson" userId="bbe8ee3e1743ce4e" providerId="LiveId" clId="{76C9B083-C5CE-54A4-81E8-16672380D724}" dt="2026-07-21T19:47:57.373" v="303" actId="1076"/>
+          <ac:picMkLst>
+            <pc:docMk/>
+            <pc:sldMk cId="3762900069" sldId="261"/>
+            <ac:picMk id="4" creationId="{8741317B-D7ED-B9E7-07C9-6A9F48B48040}"/>
+          </ac:picMkLst>
+        </pc:picChg>
+        <pc:picChg chg="add mod">
+          <ac:chgData name="Lars Pettersson" userId="bbe8ee3e1743ce4e" providerId="LiveId" clId="{76C9B083-C5CE-54A4-81E8-16672380D724}" dt="2026-07-21T19:48:01.622" v="305" actId="1076"/>
+          <ac:picMkLst>
+            <pc:docMk/>
+            <pc:sldMk cId="3762900069" sldId="261"/>
+            <ac:picMk id="5" creationId="{A1EA77B2-1690-C991-E211-5DD67C1A2D7A}"/>
+          </ac:picMkLst>
+        </pc:picChg>
+        <pc:picChg chg="add mod">
+          <ac:chgData name="Lars Pettersson" userId="bbe8ee3e1743ce4e" providerId="LiveId" clId="{76C9B083-C5CE-54A4-81E8-16672380D724}" dt="2026-07-21T19:56:20.799" v="309" actId="1076"/>
+          <ac:picMkLst>
+            <pc:docMk/>
+            <pc:sldMk cId="3762900069" sldId="261"/>
+            <ac:picMk id="6" creationId="{39ADA52D-F07E-7A11-8007-0385700D11ED}"/>
+          </ac:picMkLst>
+        </pc:picChg>
+      </pc:sldChg>
+      <pc:sldChg chg="modSp new mod">
+        <pc:chgData name="Lars Pettersson" userId="bbe8ee3e1743ce4e" providerId="LiveId" clId="{76C9B083-C5CE-54A4-81E8-16672380D724}" dt="2026-07-21T20:48:28.411" v="365" actId="27636"/>
+        <pc:sldMkLst>
+          <pc:docMk/>
+          <pc:sldMk cId="3811551630" sldId="262"/>
+        </pc:sldMkLst>
+        <pc:spChg chg="mod">
+          <ac:chgData name="Lars Pettersson" userId="bbe8ee3e1743ce4e" providerId="LiveId" clId="{76C9B083-C5CE-54A4-81E8-16672380D724}" dt="2026-07-21T20:48:26.844" v="363" actId="20577"/>
+          <ac:spMkLst>
+            <pc:docMk/>
+            <pc:sldMk cId="3811551630" sldId="262"/>
+            <ac:spMk id="2" creationId="{5C4C6A4B-A9A6-09E8-6BF4-2F3F16730C4D}"/>
+          </ac:spMkLst>
+        </pc:spChg>
+        <pc:spChg chg="mod">
+          <ac:chgData name="Lars Pettersson" userId="bbe8ee3e1743ce4e" providerId="LiveId" clId="{76C9B083-C5CE-54A4-81E8-16672380D724}" dt="2026-07-21T20:48:28.411" v="365" actId="27636"/>
+          <ac:spMkLst>
+            <pc:docMk/>
+            <pc:sldMk cId="3811551630" sldId="262"/>
+            <ac:spMk id="3" creationId="{8835C56B-BA69-4DE7-8A10-AC5FB8BA44D0}"/>
+          </ac:spMkLst>
+        </pc:spChg>
+      </pc:sldChg>
+      <pc:sldChg chg="modSp new mod">
+        <pc:chgData name="Lars Pettersson" userId="bbe8ee3e1743ce4e" providerId="LiveId" clId="{76C9B083-C5CE-54A4-81E8-16672380D724}" dt="2026-07-21T21:24:18.875" v="545" actId="20577"/>
+        <pc:sldMkLst>
+          <pc:docMk/>
+          <pc:sldMk cId="59111721" sldId="263"/>
+        </pc:sldMkLst>
+        <pc:spChg chg="mod">
+          <ac:chgData name="Lars Pettersson" userId="bbe8ee3e1743ce4e" providerId="LiveId" clId="{76C9B083-C5CE-54A4-81E8-16672380D724}" dt="2026-07-21T21:22:57.886" v="391" actId="20577"/>
+          <ac:spMkLst>
+            <pc:docMk/>
+            <pc:sldMk cId="59111721" sldId="263"/>
+            <ac:spMk id="2" creationId="{C6CFE8D1-969A-BDF5-E496-43644B08DA0B}"/>
+          </ac:spMkLst>
+        </pc:spChg>
+        <pc:spChg chg="mod">
+          <ac:chgData name="Lars Pettersson" userId="bbe8ee3e1743ce4e" providerId="LiveId" clId="{76C9B083-C5CE-54A4-81E8-16672380D724}" dt="2026-07-21T21:24:18.875" v="545" actId="20577"/>
+          <ac:spMkLst>
+            <pc:docMk/>
+            <pc:sldMk cId="59111721" sldId="263"/>
+            <ac:spMk id="3" creationId="{33E41D33-D379-6209-A358-C75E0902B1FD}"/>
+          </ac:spMkLst>
+        </pc:spChg>
       </pc:sldChg>
     </pc:docChg>
   </pc:docChgLst>
@@ -3748,6 +3953,848 @@
 </p:sld>
 </file>
 
+<file path=ppt/slides/slide3.xml><?xml version="1.0" encoding="utf-8"?>
+<p:sld xmlns:a="http://schemas.openxmlformats.org/drawingml/2006/main" xmlns:r="http://schemas.openxmlformats.org/officeDocument/2006/relationships" xmlns:p="http://schemas.openxmlformats.org/presentationml/2006/main">
+  <p:cSld>
+    <p:spTree>
+      <p:nvGrpSpPr>
+        <p:cNvPr id="1" name=""/>
+        <p:cNvGrpSpPr/>
+        <p:nvPr/>
+      </p:nvGrpSpPr>
+      <p:grpSpPr>
+        <a:xfrm>
+          <a:off x="0" y="0"/>
+          <a:ext cx="0" cy="0"/>
+          <a:chOff x="0" y="0"/>
+          <a:chExt cx="0" cy="0"/>
+        </a:xfrm>
+      </p:grpSpPr>
+      <p:sp>
+        <p:nvSpPr>
+          <p:cNvPr id="2" name="Title 1">
+            <a:extLst>
+              <a:ext uri="{FF2B5EF4-FFF2-40B4-BE49-F238E27FC236}">
+                <a16:creationId xmlns:a16="http://schemas.microsoft.com/office/drawing/2014/main" id="{F3565B0E-85EC-C1F0-9D40-0C6F287C30EB}"/>
+              </a:ext>
+            </a:extLst>
+          </p:cNvPr>
+          <p:cNvSpPr>
+            <a:spLocks noGrp="1"/>
+          </p:cNvSpPr>
+          <p:nvPr>
+            <p:ph type="title"/>
+          </p:nvPr>
+        </p:nvSpPr>
+        <p:spPr/>
+        <p:txBody>
+          <a:bodyPr/>
+          <a:lstStyle/>
+          <a:p>
+            <a:r>
+              <a:rPr lang="en-US" dirty="0"/>
+              <a:t>Refactoring the design system library HFA DS</a:t>
+            </a:r>
+          </a:p>
+        </p:txBody>
+      </p:sp>
+      <p:pic>
+        <p:nvPicPr>
+          <p:cNvPr id="4" name="Picture 3">
+            <a:extLst>
+              <a:ext uri="{FF2B5EF4-FFF2-40B4-BE49-F238E27FC236}">
+                <a16:creationId xmlns:a16="http://schemas.microsoft.com/office/drawing/2014/main" id="{50054214-4128-FA97-4963-AE24CC8545D9}"/>
+              </a:ext>
+            </a:extLst>
+          </p:cNvPr>
+          <p:cNvPicPr>
+            <a:picLocks noChangeAspect="1"/>
+          </p:cNvPicPr>
+          <p:nvPr/>
+        </p:nvPicPr>
+        <p:blipFill>
+          <a:blip r:embed="rId2"/>
+          <a:stretch>
+            <a:fillRect/>
+          </a:stretch>
+        </p:blipFill>
+        <p:spPr>
+          <a:xfrm>
+            <a:off x="4298092" y="1487504"/>
+            <a:ext cx="7772400" cy="5118665"/>
+          </a:xfrm>
+          <a:prstGeom prst="rect">
+            <a:avLst/>
+          </a:prstGeom>
+        </p:spPr>
+      </p:pic>
+    </p:spTree>
+    <p:extLst>
+      <p:ext uri="{BB962C8B-B14F-4D97-AF65-F5344CB8AC3E}">
+        <p14:creationId xmlns:p14="http://schemas.microsoft.com/office/powerpoint/2010/main" val="3747206509"/>
+      </p:ext>
+    </p:extLst>
+  </p:cSld>
+  <p:clrMapOvr>
+    <a:masterClrMapping/>
+  </p:clrMapOvr>
+</p:sld>
+</file>
+
+<file path=ppt/slides/slide4.xml><?xml version="1.0" encoding="utf-8"?>
+<p:sld xmlns:a="http://schemas.openxmlformats.org/drawingml/2006/main" xmlns:r="http://schemas.openxmlformats.org/officeDocument/2006/relationships" xmlns:p="http://schemas.openxmlformats.org/presentationml/2006/main">
+  <p:cSld>
+    <p:spTree>
+      <p:nvGrpSpPr>
+        <p:cNvPr id="1" name=""/>
+        <p:cNvGrpSpPr/>
+        <p:nvPr/>
+      </p:nvGrpSpPr>
+      <p:grpSpPr>
+        <a:xfrm>
+          <a:off x="0" y="0"/>
+          <a:ext cx="0" cy="0"/>
+          <a:chOff x="0" y="0"/>
+          <a:chExt cx="0" cy="0"/>
+        </a:xfrm>
+      </p:grpSpPr>
+      <p:sp>
+        <p:nvSpPr>
+          <p:cNvPr id="2" name="Title 1">
+            <a:extLst>
+              <a:ext uri="{FF2B5EF4-FFF2-40B4-BE49-F238E27FC236}">
+                <a16:creationId xmlns:a16="http://schemas.microsoft.com/office/drawing/2014/main" id="{F1CECDB1-7D3A-7A83-5B7D-A007AB72549C}"/>
+              </a:ext>
+            </a:extLst>
+          </p:cNvPr>
+          <p:cNvSpPr>
+            <a:spLocks noGrp="1"/>
+          </p:cNvSpPr>
+          <p:nvPr>
+            <p:ph type="title"/>
+          </p:nvPr>
+        </p:nvSpPr>
+        <p:spPr/>
+        <p:txBody>
+          <a:bodyPr/>
+          <a:lstStyle/>
+          <a:p>
+            <a:r>
+              <a:rPr lang="en-US" dirty="0"/>
+              <a:t>Execution order</a:t>
+            </a:r>
+          </a:p>
+        </p:txBody>
+      </p:sp>
+      <p:pic>
+        <p:nvPicPr>
+          <p:cNvPr id="4" name="Content Placeholder 3">
+            <a:extLst>
+              <a:ext uri="{FF2B5EF4-FFF2-40B4-BE49-F238E27FC236}">
+                <a16:creationId xmlns:a16="http://schemas.microsoft.com/office/drawing/2014/main" id="{5D2584DA-DC7E-8B34-683C-9704D8C5F166}"/>
+              </a:ext>
+            </a:extLst>
+          </p:cNvPr>
+          <p:cNvPicPr>
+            <a:picLocks noGrp="1" noChangeAspect="1"/>
+          </p:cNvPicPr>
+          <p:nvPr>
+            <p:ph idx="1"/>
+          </p:nvPr>
+        </p:nvPicPr>
+        <p:blipFill>
+          <a:blip r:embed="rId2"/>
+          <a:stretch>
+            <a:fillRect/>
+          </a:stretch>
+        </p:blipFill>
+        <p:spPr>
+          <a:xfrm>
+            <a:off x="3690304" y="1825625"/>
+            <a:ext cx="4811391" cy="4351338"/>
+          </a:xfrm>
+          <a:prstGeom prst="rect">
+            <a:avLst/>
+          </a:prstGeom>
+        </p:spPr>
+      </p:pic>
+    </p:spTree>
+    <p:extLst>
+      <p:ext uri="{BB962C8B-B14F-4D97-AF65-F5344CB8AC3E}">
+        <p14:creationId xmlns:p14="http://schemas.microsoft.com/office/powerpoint/2010/main" val="3679306684"/>
+      </p:ext>
+    </p:extLst>
+  </p:cSld>
+  <p:clrMapOvr>
+    <a:masterClrMapping/>
+  </p:clrMapOvr>
+</p:sld>
+</file>
+
+<file path=ppt/slides/slide5.xml><?xml version="1.0" encoding="utf-8"?>
+<p:sld xmlns:a="http://schemas.openxmlformats.org/drawingml/2006/main" xmlns:r="http://schemas.openxmlformats.org/officeDocument/2006/relationships" xmlns:p="http://schemas.openxmlformats.org/presentationml/2006/main">
+  <p:cSld>
+    <p:spTree>
+      <p:nvGrpSpPr>
+        <p:cNvPr id="1" name=""/>
+        <p:cNvGrpSpPr/>
+        <p:nvPr/>
+      </p:nvGrpSpPr>
+      <p:grpSpPr>
+        <a:xfrm>
+          <a:off x="0" y="0"/>
+          <a:ext cx="0" cy="0"/>
+          <a:chOff x="0" y="0"/>
+          <a:chExt cx="0" cy="0"/>
+        </a:xfrm>
+      </p:grpSpPr>
+      <p:sp>
+        <p:nvSpPr>
+          <p:cNvPr id="2" name="Title 1">
+            <a:extLst>
+              <a:ext uri="{FF2B5EF4-FFF2-40B4-BE49-F238E27FC236}">
+                <a16:creationId xmlns:a16="http://schemas.microsoft.com/office/drawing/2014/main" id="{38491A15-B9B9-97A3-92B4-CAE77F2E2C29}"/>
+              </a:ext>
+            </a:extLst>
+          </p:cNvPr>
+          <p:cNvSpPr>
+            <a:spLocks noGrp="1"/>
+          </p:cNvSpPr>
+          <p:nvPr>
+            <p:ph type="title"/>
+          </p:nvPr>
+        </p:nvSpPr>
+        <p:spPr/>
+        <p:txBody>
+          <a:bodyPr/>
+          <a:lstStyle/>
+          <a:p>
+            <a:r>
+              <a:rPr lang="en-US"/>
+              <a:t>Plan To-dos</a:t>
+            </a:r>
+            <a:endParaRPr lang="en-US" dirty="0"/>
+          </a:p>
+        </p:txBody>
+      </p:sp>
+      <p:pic>
+        <p:nvPicPr>
+          <p:cNvPr id="5" name="Content Placeholder 4">
+            <a:extLst>
+              <a:ext uri="{FF2B5EF4-FFF2-40B4-BE49-F238E27FC236}">
+                <a16:creationId xmlns:a16="http://schemas.microsoft.com/office/drawing/2014/main" id="{BEABF87E-C70D-9F6A-7E5C-93B2F011562F}"/>
+              </a:ext>
+            </a:extLst>
+          </p:cNvPr>
+          <p:cNvPicPr>
+            <a:picLocks noGrp="1" noChangeAspect="1"/>
+          </p:cNvPicPr>
+          <p:nvPr>
+            <p:ph idx="1"/>
+          </p:nvPr>
+        </p:nvPicPr>
+        <p:blipFill>
+          <a:blip r:embed="rId2"/>
+          <a:stretch>
+            <a:fillRect/>
+          </a:stretch>
+        </p:blipFill>
+        <p:spPr>
+          <a:xfrm>
+            <a:off x="1276350" y="1918494"/>
+            <a:ext cx="9639300" cy="4165600"/>
+          </a:xfrm>
+          <a:prstGeom prst="rect">
+            <a:avLst/>
+          </a:prstGeom>
+        </p:spPr>
+      </p:pic>
+    </p:spTree>
+    <p:extLst>
+      <p:ext uri="{BB962C8B-B14F-4D97-AF65-F5344CB8AC3E}">
+        <p14:creationId xmlns:p14="http://schemas.microsoft.com/office/powerpoint/2010/main" val="1360940721"/>
+      </p:ext>
+    </p:extLst>
+  </p:cSld>
+  <p:clrMapOvr>
+    <a:masterClrMapping/>
+  </p:clrMapOvr>
+</p:sld>
+</file>
+
+<file path=ppt/slides/slide6.xml><?xml version="1.0" encoding="utf-8"?>
+<p:sld xmlns:a="http://schemas.openxmlformats.org/drawingml/2006/main" xmlns:r="http://schemas.openxmlformats.org/officeDocument/2006/relationships" xmlns:p="http://schemas.openxmlformats.org/presentationml/2006/main">
+  <p:cSld>
+    <p:spTree>
+      <p:nvGrpSpPr>
+        <p:cNvPr id="1" name=""/>
+        <p:cNvGrpSpPr/>
+        <p:nvPr/>
+      </p:nvGrpSpPr>
+      <p:grpSpPr>
+        <a:xfrm>
+          <a:off x="0" y="0"/>
+          <a:ext cx="0" cy="0"/>
+          <a:chOff x="0" y="0"/>
+          <a:chExt cx="0" cy="0"/>
+        </a:xfrm>
+      </p:grpSpPr>
+      <p:sp>
+        <p:nvSpPr>
+          <p:cNvPr id="2" name="Title 1">
+            <a:extLst>
+              <a:ext uri="{FF2B5EF4-FFF2-40B4-BE49-F238E27FC236}">
+                <a16:creationId xmlns:a16="http://schemas.microsoft.com/office/drawing/2014/main" id="{A10DAAD5-D6ED-BFCC-B880-C576B6937BC3}"/>
+              </a:ext>
+            </a:extLst>
+          </p:cNvPr>
+          <p:cNvSpPr>
+            <a:spLocks noGrp="1"/>
+          </p:cNvSpPr>
+          <p:nvPr>
+            <p:ph type="title"/>
+          </p:nvPr>
+        </p:nvSpPr>
+        <p:spPr/>
+        <p:txBody>
+          <a:bodyPr/>
+          <a:lstStyle/>
+          <a:p>
+            <a:r>
+              <a:rPr lang="en-US" dirty="0"/>
+              <a:t>Not completely smooth</a:t>
+            </a:r>
+          </a:p>
+        </p:txBody>
+      </p:sp>
+      <p:pic>
+        <p:nvPicPr>
+          <p:cNvPr id="4" name="Content Placeholder 3">
+            <a:extLst>
+              <a:ext uri="{FF2B5EF4-FFF2-40B4-BE49-F238E27FC236}">
+                <a16:creationId xmlns:a16="http://schemas.microsoft.com/office/drawing/2014/main" id="{8741317B-D7ED-B9E7-07C9-6A9F48B48040}"/>
+              </a:ext>
+            </a:extLst>
+          </p:cNvPr>
+          <p:cNvPicPr>
+            <a:picLocks noGrp="1" noChangeAspect="1"/>
+          </p:cNvPicPr>
+          <p:nvPr>
+            <p:ph idx="1"/>
+          </p:nvPr>
+        </p:nvPicPr>
+        <p:blipFill>
+          <a:blip r:embed="rId2"/>
+          <a:stretch>
+            <a:fillRect/>
+          </a:stretch>
+        </p:blipFill>
+        <p:spPr>
+          <a:xfrm>
+            <a:off x="838200" y="1926840"/>
+            <a:ext cx="4711700" cy="1092200"/>
+          </a:xfrm>
+          <a:prstGeom prst="rect">
+            <a:avLst/>
+          </a:prstGeom>
+        </p:spPr>
+      </p:pic>
+      <p:pic>
+        <p:nvPicPr>
+          <p:cNvPr id="5" name="Picture 4">
+            <a:extLst>
+              <a:ext uri="{FF2B5EF4-FFF2-40B4-BE49-F238E27FC236}">
+                <a16:creationId xmlns:a16="http://schemas.microsoft.com/office/drawing/2014/main" id="{A1EA77B2-1690-C991-E211-5DD67C1A2D7A}"/>
+              </a:ext>
+            </a:extLst>
+          </p:cNvPr>
+          <p:cNvPicPr>
+            <a:picLocks noChangeAspect="1"/>
+          </p:cNvPicPr>
+          <p:nvPr/>
+        </p:nvPicPr>
+        <p:blipFill>
+          <a:blip r:embed="rId3"/>
+          <a:stretch>
+            <a:fillRect/>
+          </a:stretch>
+        </p:blipFill>
+        <p:spPr>
+          <a:xfrm>
+            <a:off x="6520906" y="1628775"/>
+            <a:ext cx="5054600" cy="4864100"/>
+          </a:xfrm>
+          <a:prstGeom prst="rect">
+            <a:avLst/>
+          </a:prstGeom>
+        </p:spPr>
+      </p:pic>
+      <p:pic>
+        <p:nvPicPr>
+          <p:cNvPr id="6" name="Picture 5">
+            <a:extLst>
+              <a:ext uri="{FF2B5EF4-FFF2-40B4-BE49-F238E27FC236}">
+                <a16:creationId xmlns:a16="http://schemas.microsoft.com/office/drawing/2014/main" id="{39ADA52D-F07E-7A11-8007-0385700D11ED}"/>
+              </a:ext>
+            </a:extLst>
+          </p:cNvPr>
+          <p:cNvPicPr>
+            <a:picLocks noChangeAspect="1"/>
+          </p:cNvPicPr>
+          <p:nvPr/>
+        </p:nvPicPr>
+        <p:blipFill>
+          <a:blip r:embed="rId4"/>
+          <a:stretch>
+            <a:fillRect/>
+          </a:stretch>
+        </p:blipFill>
+        <p:spPr>
+          <a:xfrm>
+            <a:off x="1168386" y="3255192"/>
+            <a:ext cx="4381514" cy="3473835"/>
+          </a:xfrm>
+          <a:prstGeom prst="rect">
+            <a:avLst/>
+          </a:prstGeom>
+        </p:spPr>
+      </p:pic>
+    </p:spTree>
+    <p:extLst>
+      <p:ext uri="{BB962C8B-B14F-4D97-AF65-F5344CB8AC3E}">
+        <p14:creationId xmlns:p14="http://schemas.microsoft.com/office/powerpoint/2010/main" val="3762900069"/>
+      </p:ext>
+    </p:extLst>
+  </p:cSld>
+  <p:clrMapOvr>
+    <a:masterClrMapping/>
+  </p:clrMapOvr>
+</p:sld>
+</file>
+
+<file path=ppt/slides/slide7.xml><?xml version="1.0" encoding="utf-8"?>
+<p:sld xmlns:a="http://schemas.openxmlformats.org/drawingml/2006/main" xmlns:r="http://schemas.openxmlformats.org/officeDocument/2006/relationships" xmlns:p="http://schemas.openxmlformats.org/presentationml/2006/main">
+  <p:cSld>
+    <p:spTree>
+      <p:nvGrpSpPr>
+        <p:cNvPr id="1" name=""/>
+        <p:cNvGrpSpPr/>
+        <p:nvPr/>
+      </p:nvGrpSpPr>
+      <p:grpSpPr>
+        <a:xfrm>
+          <a:off x="0" y="0"/>
+          <a:ext cx="0" cy="0"/>
+          <a:chOff x="0" y="0"/>
+          <a:chExt cx="0" cy="0"/>
+        </a:xfrm>
+      </p:grpSpPr>
+      <p:sp>
+        <p:nvSpPr>
+          <p:cNvPr id="2" name="Title 1">
+            <a:extLst>
+              <a:ext uri="{FF2B5EF4-FFF2-40B4-BE49-F238E27FC236}">
+                <a16:creationId xmlns:a16="http://schemas.microsoft.com/office/drawing/2014/main" id="{5C4C6A4B-A9A6-09E8-6BF4-2F3F16730C4D}"/>
+              </a:ext>
+            </a:extLst>
+          </p:cNvPr>
+          <p:cNvSpPr>
+            <a:spLocks noGrp="1"/>
+          </p:cNvSpPr>
+          <p:nvPr>
+            <p:ph type="title"/>
+          </p:nvPr>
+        </p:nvSpPr>
+        <p:spPr/>
+        <p:txBody>
+          <a:bodyPr/>
+          <a:lstStyle/>
+          <a:p>
+            <a:r>
+              <a:rPr lang="en-US" dirty="0"/>
+              <a:t>Component swap – need of UX</a:t>
+            </a:r>
+          </a:p>
+        </p:txBody>
+      </p:sp>
+      <p:sp>
+        <p:nvSpPr>
+          <p:cNvPr id="3" name="Content Placeholder 2">
+            <a:extLst>
+              <a:ext uri="{FF2B5EF4-FFF2-40B4-BE49-F238E27FC236}">
+                <a16:creationId xmlns:a16="http://schemas.microsoft.com/office/drawing/2014/main" id="{8835C56B-BA69-4DE7-8A10-AC5FB8BA44D0}"/>
+              </a:ext>
+            </a:extLst>
+          </p:cNvPr>
+          <p:cNvSpPr>
+            <a:spLocks noGrp="1"/>
+          </p:cNvSpPr>
+          <p:nvPr>
+            <p:ph idx="1"/>
+          </p:nvPr>
+        </p:nvSpPr>
+        <p:spPr/>
+        <p:txBody>
+          <a:bodyPr>
+            <a:normAutofit fontScale="70000" lnSpcReduction="20000"/>
+          </a:bodyPr>
+          <a:lstStyle/>
+          <a:p>
+            <a:r>
+              <a:rPr lang="en-US" b="1" dirty="0"/>
+              <a:t>Title:</a:t>
+            </a:r>
+            <a:r>
+              <a:rPr lang="en-US" dirty="0"/>
+              <a:t> Swap component picker should show variant property values, not duplicate component names</a:t>
+            </a:r>
+          </a:p>
+          <a:p>
+            <a:r>
+              <a:rPr lang="en-US" b="1" dirty="0"/>
+              <a:t>Problem:</a:t>
+            </a:r>
+            <a:r>
+              <a:rPr lang="en-US" dirty="0"/>
+              <a:t> When swapping to a component with variants (e.g. HFA DS </a:t>
+            </a:r>
+            <a:r>
+              <a:rPr lang="en-US" b="1" dirty="0"/>
+              <a:t>Action Button</a:t>
+            </a:r>
+            <a:r>
+              <a:rPr lang="en-US" dirty="0"/>
+              <a:t>), the picker lists many rows all named “Action Button” with no Type/State (or Strength/Status) labels — indistinguishable without trial and error.</a:t>
+            </a:r>
+          </a:p>
+          <a:p>
+            <a:r>
+              <a:rPr lang="en-US" b="1" dirty="0"/>
+              <a:t>Expected:</a:t>
+            </a:r>
+            <a:r>
+              <a:rPr lang="en-US" dirty="0"/>
+              <a:t> Each row shows variant props (e.g. Action Button · Cause · Unselected) or groups variants under one entry with a variant selector in the picker.</a:t>
+            </a:r>
+          </a:p>
+          <a:p>
+            <a:r>
+              <a:rPr lang="en-US" b="1" dirty="0"/>
+              <a:t>Workaround today:</a:t>
+            </a:r>
+            <a:r>
+              <a:rPr lang="en-US" dirty="0"/>
+              <a:t> Swap to any entry in the family, then set </a:t>
+            </a:r>
+            <a:r>
+              <a:rPr lang="en-US" b="1" dirty="0"/>
+              <a:t>Type / State</a:t>
+            </a:r>
+            <a:r>
+              <a:rPr lang="en-US" dirty="0"/>
+              <a:t> (or other props) in the Design panel.</a:t>
+            </a:r>
+          </a:p>
+          <a:p>
+            <a:r>
+              <a:rPr lang="en-US" b="1" dirty="0"/>
+              <a:t>Where to file:</a:t>
+            </a:r>
+            <a:endParaRPr lang="en-US" dirty="0"/>
+          </a:p>
+          <a:p>
+            <a:pPr lvl="0"/>
+            <a:r>
+              <a:rPr lang="en-US" dirty="0"/>
+              <a:t>Comment on the </a:t>
+            </a:r>
+            <a:r>
+              <a:rPr lang="en-US" dirty="0">
+                <a:hlinkClick r:id="rId2"/>
+              </a:rPr>
+              <a:t>community thread</a:t>
+            </a:r>
+            <a:r>
+              <a:rPr lang="en-US" dirty="0"/>
+              <a:t>, or</a:t>
+            </a:r>
+          </a:p>
+          <a:p>
+            <a:pPr lvl="0"/>
+            <a:r>
+              <a:rPr lang="en-US" dirty="0"/>
+              <a:t>New issue at </a:t>
+            </a:r>
+            <a:r>
+              <a:rPr lang="en-US" dirty="0">
+                <a:hlinkClick r:id="rId3"/>
+              </a:rPr>
+              <a:t>github.com/penpot/penpot/issues</a:t>
+            </a:r>
+            <a:r>
+              <a:rPr lang="en-US" dirty="0"/>
+              <a:t> with label enhancement and a screenshot like yours.</a:t>
+            </a:r>
+          </a:p>
+          <a:p>
+            <a:r>
+              <a:rPr lang="en-US" dirty="0"/>
+              <a:t>That’s a fair report — the swap search was improved in </a:t>
+            </a:r>
+            <a:r>
+              <a:rPr lang="en-US" dirty="0">
+                <a:hlinkClick r:id="rId4"/>
+              </a:rPr>
+              <a:t>PR #3750</a:t>
+            </a:r>
+            <a:r>
+              <a:rPr lang="en-US" dirty="0"/>
+              <a:t>, but </a:t>
+            </a:r>
+            <a:r>
+              <a:rPr lang="en-US" b="1" dirty="0"/>
+              <a:t>variant labels in the swap list</a:t>
+            </a:r>
+            <a:r>
+              <a:rPr lang="en-US" dirty="0"/>
+              <a:t> still aren’t there.</a:t>
+            </a:r>
+          </a:p>
+          <a:p>
+            <a:endParaRPr lang="en-US" dirty="0"/>
+          </a:p>
+        </p:txBody>
+      </p:sp>
+    </p:spTree>
+    <p:extLst>
+      <p:ext uri="{BB962C8B-B14F-4D97-AF65-F5344CB8AC3E}">
+        <p14:creationId xmlns:p14="http://schemas.microsoft.com/office/powerpoint/2010/main" val="3811551630"/>
+      </p:ext>
+    </p:extLst>
+  </p:cSld>
+  <p:clrMapOvr>
+    <a:masterClrMapping/>
+  </p:clrMapOvr>
+</p:sld>
+</file>
+
+<file path=ppt/slides/slide8.xml><?xml version="1.0" encoding="utf-8"?>
+<p:sld xmlns:a="http://schemas.openxmlformats.org/drawingml/2006/main" xmlns:r="http://schemas.openxmlformats.org/officeDocument/2006/relationships" xmlns:p="http://schemas.openxmlformats.org/presentationml/2006/main">
+  <p:cSld>
+    <p:spTree>
+      <p:nvGrpSpPr>
+        <p:cNvPr id="1" name=""/>
+        <p:cNvGrpSpPr/>
+        <p:nvPr/>
+      </p:nvGrpSpPr>
+      <p:grpSpPr>
+        <a:xfrm>
+          <a:off x="0" y="0"/>
+          <a:ext cx="0" cy="0"/>
+          <a:chOff x="0" y="0"/>
+          <a:chExt cx="0" cy="0"/>
+        </a:xfrm>
+      </p:grpSpPr>
+      <p:sp>
+        <p:nvSpPr>
+          <p:cNvPr id="2" name="Title 1">
+            <a:extLst>
+              <a:ext uri="{FF2B5EF4-FFF2-40B4-BE49-F238E27FC236}">
+                <a16:creationId xmlns:a16="http://schemas.microsoft.com/office/drawing/2014/main" id="{C6CFE8D1-969A-BDF5-E496-43644B08DA0B}"/>
+              </a:ext>
+            </a:extLst>
+          </p:cNvPr>
+          <p:cNvSpPr>
+            <a:spLocks noGrp="1"/>
+          </p:cNvSpPr>
+          <p:nvPr>
+            <p:ph type="title"/>
+          </p:nvPr>
+        </p:nvSpPr>
+        <p:spPr/>
+        <p:txBody>
+          <a:bodyPr/>
+          <a:lstStyle/>
+          <a:p>
+            <a:r>
+              <a:rPr lang="en-US" dirty="0"/>
+              <a:t>Possible MCP Bug?</a:t>
+            </a:r>
+          </a:p>
+        </p:txBody>
+      </p:sp>
+      <p:sp>
+        <p:nvSpPr>
+          <p:cNvPr id="3" name="Content Placeholder 2">
+            <a:extLst>
+              <a:ext uri="{FF2B5EF4-FFF2-40B4-BE49-F238E27FC236}">
+                <a16:creationId xmlns:a16="http://schemas.microsoft.com/office/drawing/2014/main" id="{33E41D33-D379-6209-A358-C75E0902B1FD}"/>
+              </a:ext>
+            </a:extLst>
+          </p:cNvPr>
+          <p:cNvSpPr>
+            <a:spLocks noGrp="1"/>
+          </p:cNvSpPr>
+          <p:nvPr>
+            <p:ph idx="1"/>
+          </p:nvPr>
+        </p:nvSpPr>
+        <p:spPr/>
+        <p:txBody>
+          <a:bodyPr>
+            <a:normAutofit fontScale="85000" lnSpcReduction="20000"/>
+          </a:bodyPr>
+          <a:lstStyle/>
+          <a:p>
+            <a:r>
+              <a:rPr lang="en-US" b="1" dirty="0" err="1"/>
+              <a:t>Penpot</a:t>
+            </a:r>
+            <a:r>
+              <a:rPr lang="en-US" b="1" dirty="0"/>
+              <a:t> (</a:t>
+            </a:r>
+            <a:r>
+              <a:rPr lang="en-US" b="1" dirty="0" err="1"/>
+              <a:t>github.com</a:t>
+            </a:r>
+            <a:r>
+              <a:rPr lang="en-US" b="1" dirty="0"/>
+              <a:t>/</a:t>
+            </a:r>
+            <a:r>
+              <a:rPr lang="en-US" b="1" dirty="0" err="1"/>
+              <a:t>penpot</a:t>
+            </a:r>
+            <a:r>
+              <a:rPr lang="en-US" b="1" dirty="0"/>
+              <a:t>/</a:t>
+            </a:r>
+            <a:r>
+              <a:rPr lang="en-US" b="1" dirty="0" err="1"/>
+              <a:t>penpot</a:t>
+            </a:r>
+            <a:r>
+              <a:rPr lang="en-US" b="1" dirty="0"/>
+              <a:t>) — bugs</a:t>
+            </a:r>
+            <a:endParaRPr lang="en-US" dirty="0"/>
+          </a:p>
+          <a:p>
+            <a:pPr lvl="0"/>
+            <a:r>
+              <a:rPr lang="en-US" dirty="0"/>
+              <a:t>Connected library sometimes shows inflated component count (69 vs 13) until reload</a:t>
+            </a:r>
+          </a:p>
+          <a:p>
+            <a:pPr lvl="0"/>
+            <a:r>
+              <a:rPr lang="en-US" dirty="0"/>
+              <a:t>Swap fails with generic “Something wrong has happened” until library cache refresh</a:t>
+            </a:r>
+          </a:p>
+          <a:p>
+            <a:r>
+              <a:rPr lang="en-US" b="1" dirty="0" err="1"/>
+              <a:t>Penpot</a:t>
+            </a:r>
+            <a:r>
+              <a:rPr lang="en-US" b="1" dirty="0"/>
+              <a:t> — enhancement</a:t>
+            </a:r>
+            <a:r>
+              <a:rPr lang="en-US" dirty="0"/>
+              <a:t> 3. Swap picker should show variant props (Type/State, etc.) when a component has variants (HR.: not sure about this one – makes the interface </a:t>
+            </a:r>
+            <a:r>
+              <a:rPr lang="en-US" dirty="0" err="1"/>
+              <a:t>clutered</a:t>
+            </a:r>
+            <a:r>
+              <a:rPr lang="en-US" dirty="0"/>
+              <a:t> – but great feature if it </a:t>
+            </a:r>
+            <a:r>
+              <a:rPr lang="en-US"/>
+              <a:t>works in </a:t>
+            </a:r>
+            <a:r>
+              <a:rPr lang="en-US" dirty="0"/>
+              <a:t>MCP)</a:t>
+            </a:r>
+          </a:p>
+          <a:p>
+            <a:r>
+              <a:rPr lang="en-US" b="1" dirty="0" err="1"/>
+              <a:t>Penpot</a:t>
+            </a:r>
+            <a:r>
+              <a:rPr lang="en-US" b="1" dirty="0"/>
+              <a:t> MCP / plugin (if you use Cursor’s </a:t>
+            </a:r>
+            <a:r>
+              <a:rPr lang="en-US" b="1" dirty="0" err="1"/>
+              <a:t>Penpot</a:t>
+            </a:r>
+            <a:r>
+              <a:rPr lang="en-US" b="1" dirty="0"/>
+              <a:t> MCP) — bug</a:t>
+            </a:r>
+            <a:r>
+              <a:rPr lang="en-US" dirty="0"/>
+              <a:t> 4. </a:t>
+            </a:r>
+            <a:r>
+              <a:rPr lang="en-US" dirty="0" err="1"/>
+              <a:t>swapComponent</a:t>
+            </a:r>
+            <a:r>
+              <a:rPr lang="en-US" dirty="0"/>
+              <a:t>() succeeds but doesn’t change component().</a:t>
+            </a:r>
+            <a:r>
+              <a:rPr lang="en-US" dirty="0" err="1"/>
+              <a:t>libraryId</a:t>
+            </a:r>
+            <a:r>
+              <a:rPr lang="en-US" dirty="0"/>
+              <a:t> cross-library</a:t>
+            </a:r>
+            <a:br>
+              <a:rPr lang="en-US" dirty="0"/>
+            </a:br>
+            <a:r>
+              <a:rPr lang="en-US" dirty="0"/>
+              <a:t>5. </a:t>
+            </a:r>
+            <a:r>
+              <a:rPr lang="en-US" dirty="0" err="1"/>
+              <a:t>LibraryComponent.instance</a:t>
+            </a:r>
+            <a:r>
+              <a:rPr lang="en-US" dirty="0"/>
+              <a:t>() returns non-usable shapes from connected libraries</a:t>
+            </a:r>
+          </a:p>
+          <a:p>
+            <a:endParaRPr lang="en-US" dirty="0"/>
+          </a:p>
+        </p:txBody>
+      </p:sp>
+    </p:spTree>
+    <p:extLst>
+      <p:ext uri="{BB962C8B-B14F-4D97-AF65-F5344CB8AC3E}">
+        <p14:creationId xmlns:p14="http://schemas.microsoft.com/office/powerpoint/2010/main" val="59111721"/>
+      </p:ext>
+    </p:extLst>
+  </p:cSld>
+  <p:clrMapOvr>
+    <a:masterClrMapping/>
+  </p:clrMapOvr>
+</p:sld>
+</file>
+
 <file path=ppt/theme/theme1.xml><?xml version="1.0" encoding="utf-8"?>
 <a:theme xmlns:a="http://schemas.openxmlformats.org/drawingml/2006/main" name="Office Theme">
   <a:themeElements>

</xml_diff>

<commit_message>
Promote Bowtie.html as the sole app entry and remove legacy prototypes.
Adds state-driven keyboard/import validation work, traffic fixtures, and
docs updates so the app no longer depends on prototype.html / 3 / 4.

Co-authored-by: Cursor <cursoragent@cursor.com>
</commit_message>
<xml_diff>
--- a/bowtie_design_notes.pptx
+++ b/bowtie_design_notes.pptx
@@ -6,13 +6,20 @@
   </p:sldMasterIdLst>
   <p:sldIdLst>
     <p:sldId id="256" r:id="rId2"/>
-    <p:sldId id="257" r:id="rId3"/>
-    <p:sldId id="258" r:id="rId4"/>
-    <p:sldId id="259" r:id="rId5"/>
-    <p:sldId id="260" r:id="rId6"/>
-    <p:sldId id="261" r:id="rId7"/>
-    <p:sldId id="262" r:id="rId8"/>
-    <p:sldId id="263" r:id="rId9"/>
+    <p:sldId id="264" r:id="rId3"/>
+    <p:sldId id="257" r:id="rId4"/>
+    <p:sldId id="258" r:id="rId5"/>
+    <p:sldId id="259" r:id="rId6"/>
+    <p:sldId id="260" r:id="rId7"/>
+    <p:sldId id="261" r:id="rId8"/>
+    <p:sldId id="262" r:id="rId9"/>
+    <p:sldId id="263" r:id="rId10"/>
+    <p:sldId id="265" r:id="rId11"/>
+    <p:sldId id="266" r:id="rId12"/>
+    <p:sldId id="267" r:id="rId13"/>
+    <p:sldId id="269" r:id="rId14"/>
+    <p:sldId id="268" r:id="rId15"/>
+    <p:sldId id="270" r:id="rId16"/>
   </p:sldIdLst>
   <p:sldSz cx="12192000" cy="6858000"/>
   <p:notesSz cx="6858000" cy="9144000"/>
@@ -122,7 +129,7 @@
 <file path=ppt/revisionInfo.xml><?xml version="1.0" encoding="utf-8"?>
 <p1510:revInfo xmlns:a="http://schemas.openxmlformats.org/drawingml/2006/main" xmlns:r="http://schemas.openxmlformats.org/officeDocument/2006/relationships" xmlns:p1510="http://schemas.microsoft.com/office/powerpoint/2015/10/main">
   <p1510:revLst>
-    <p1510:client id="{3BCA02BA-0FB2-DA4B-8BBC-CE8B401E8468}" v="15" dt="2026-07-21T21:23:00.041"/>
+    <p1510:client id="{3BCA02BA-0FB2-DA4B-8BBC-CE8B401E8468}" v="24" dt="2026-07-22T22:12:23.226"/>
   </p1510:revLst>
 </p1510:revInfo>
 </file>
@@ -131,8 +138,8 @@
 <pc:chgInfo xmlns:a="http://schemas.openxmlformats.org/drawingml/2006/main" xmlns:r="http://schemas.openxmlformats.org/officeDocument/2006/relationships" xmlns:ac="http://schemas.microsoft.com/office/drawing/2013/main/command" xmlns:pc="http://schemas.microsoft.com/office/powerpoint/2013/main/command">
   <pc:docChgLst>
     <pc:chgData name="Lars Pettersson" userId="bbe8ee3e1743ce4e" providerId="LiveId" clId="{76C9B083-C5CE-54A4-81E8-16672380D724}"/>
-    <pc:docChg chg="undo custSel addSld modSld">
-      <pc:chgData name="Lars Pettersson" userId="bbe8ee3e1743ce4e" providerId="LiveId" clId="{76C9B083-C5CE-54A4-81E8-16672380D724}" dt="2026-07-21T21:24:18.875" v="545" actId="20577"/>
+    <pc:docChg chg="undo custSel addSld modSld sldOrd">
+      <pc:chgData name="Lars Pettersson" userId="bbe8ee3e1743ce4e" providerId="LiveId" clId="{76C9B083-C5CE-54A4-81E8-16672380D724}" dt="2026-07-22T22:12:23.226" v="568"/>
       <pc:docMkLst>
         <pc:docMk/>
       </pc:docMkLst>
@@ -416,6 +423,231 @@
           </ac:spMkLst>
         </pc:spChg>
       </pc:sldChg>
+      <pc:sldChg chg="addSp delSp modSp new mod">
+        <pc:chgData name="Lars Pettersson" userId="bbe8ee3e1743ce4e" providerId="LiveId" clId="{76C9B083-C5CE-54A4-81E8-16672380D724}" dt="2026-07-22T09:02:22.941" v="548"/>
+        <pc:sldMkLst>
+          <pc:docMk/>
+          <pc:sldMk cId="1650482976" sldId="264"/>
+        </pc:sldMkLst>
+        <pc:spChg chg="del">
+          <ac:chgData name="Lars Pettersson" userId="bbe8ee3e1743ce4e" providerId="LiveId" clId="{76C9B083-C5CE-54A4-81E8-16672380D724}" dt="2026-07-22T09:02:03.432" v="547" actId="478"/>
+          <ac:spMkLst>
+            <pc:docMk/>
+            <pc:sldMk cId="1650482976" sldId="264"/>
+            <ac:spMk id="2" creationId="{54D4D2D6-1D52-F88B-EC7A-433C645E765E}"/>
+          </ac:spMkLst>
+        </pc:spChg>
+        <pc:spChg chg="del">
+          <ac:chgData name="Lars Pettersson" userId="bbe8ee3e1743ce4e" providerId="LiveId" clId="{76C9B083-C5CE-54A4-81E8-16672380D724}" dt="2026-07-22T09:02:03.432" v="547" actId="478"/>
+          <ac:spMkLst>
+            <pc:docMk/>
+            <pc:sldMk cId="1650482976" sldId="264"/>
+            <ac:spMk id="3" creationId="{DE454593-F4DF-683D-7462-CEDE51CB4437}"/>
+          </ac:spMkLst>
+        </pc:spChg>
+        <pc:picChg chg="add mod">
+          <ac:chgData name="Lars Pettersson" userId="bbe8ee3e1743ce4e" providerId="LiveId" clId="{76C9B083-C5CE-54A4-81E8-16672380D724}" dt="2026-07-22T09:02:22.941" v="548"/>
+          <ac:picMkLst>
+            <pc:docMk/>
+            <pc:sldMk cId="1650482976" sldId="264"/>
+            <ac:picMk id="4" creationId="{8E8615E9-AF47-9ECC-16FC-8191BD9D1CE3}"/>
+          </ac:picMkLst>
+        </pc:picChg>
+      </pc:sldChg>
+      <pc:sldChg chg="addSp delSp modSp new mod">
+        <pc:chgData name="Lars Pettersson" userId="bbe8ee3e1743ce4e" providerId="LiveId" clId="{76C9B083-C5CE-54A4-81E8-16672380D724}" dt="2026-07-22T21:56:35.147" v="551"/>
+        <pc:sldMkLst>
+          <pc:docMk/>
+          <pc:sldMk cId="1586328075" sldId="265"/>
+        </pc:sldMkLst>
+        <pc:spChg chg="del">
+          <ac:chgData name="Lars Pettersson" userId="bbe8ee3e1743ce4e" providerId="LiveId" clId="{76C9B083-C5CE-54A4-81E8-16672380D724}" dt="2026-07-22T21:56:34.552" v="550" actId="478"/>
+          <ac:spMkLst>
+            <pc:docMk/>
+            <pc:sldMk cId="1586328075" sldId="265"/>
+            <ac:spMk id="2" creationId="{DA390228-424F-0C7F-94DE-CA70C18F1CC8}"/>
+          </ac:spMkLst>
+        </pc:spChg>
+        <pc:spChg chg="del">
+          <ac:chgData name="Lars Pettersson" userId="bbe8ee3e1743ce4e" providerId="LiveId" clId="{76C9B083-C5CE-54A4-81E8-16672380D724}" dt="2026-07-22T21:56:34.552" v="550" actId="478"/>
+          <ac:spMkLst>
+            <pc:docMk/>
+            <pc:sldMk cId="1586328075" sldId="265"/>
+            <ac:spMk id="3" creationId="{7EA0401F-3486-8215-CBD2-9A338AF3508F}"/>
+          </ac:spMkLst>
+        </pc:spChg>
+        <pc:picChg chg="add mod">
+          <ac:chgData name="Lars Pettersson" userId="bbe8ee3e1743ce4e" providerId="LiveId" clId="{76C9B083-C5CE-54A4-81E8-16672380D724}" dt="2026-07-22T21:56:35.147" v="551"/>
+          <ac:picMkLst>
+            <pc:docMk/>
+            <pc:sldMk cId="1586328075" sldId="265"/>
+            <ac:picMk id="4" creationId="{00A3418D-F54E-9511-0CC1-626C987B9737}"/>
+          </ac:picMkLst>
+        </pc:picChg>
+      </pc:sldChg>
+      <pc:sldChg chg="addSp delSp new mod">
+        <pc:chgData name="Lars Pettersson" userId="bbe8ee3e1743ce4e" providerId="LiveId" clId="{76C9B083-C5CE-54A4-81E8-16672380D724}" dt="2026-07-22T21:58:07.771" v="554"/>
+        <pc:sldMkLst>
+          <pc:docMk/>
+          <pc:sldMk cId="3359188529" sldId="266"/>
+        </pc:sldMkLst>
+        <pc:spChg chg="del">
+          <ac:chgData name="Lars Pettersson" userId="bbe8ee3e1743ce4e" providerId="LiveId" clId="{76C9B083-C5CE-54A4-81E8-16672380D724}" dt="2026-07-22T21:58:07.174" v="553" actId="478"/>
+          <ac:spMkLst>
+            <pc:docMk/>
+            <pc:sldMk cId="3359188529" sldId="266"/>
+            <ac:spMk id="2" creationId="{FA7249C2-497F-5FB5-5CD0-375399EA8347}"/>
+          </ac:spMkLst>
+        </pc:spChg>
+        <pc:spChg chg="del">
+          <ac:chgData name="Lars Pettersson" userId="bbe8ee3e1743ce4e" providerId="LiveId" clId="{76C9B083-C5CE-54A4-81E8-16672380D724}" dt="2026-07-22T21:58:07.174" v="553" actId="478"/>
+          <ac:spMkLst>
+            <pc:docMk/>
+            <pc:sldMk cId="3359188529" sldId="266"/>
+            <ac:spMk id="3" creationId="{2EBEC353-A4FD-9647-99E7-8DE472A6FAB8}"/>
+          </ac:spMkLst>
+        </pc:spChg>
+        <pc:picChg chg="add">
+          <ac:chgData name="Lars Pettersson" userId="bbe8ee3e1743ce4e" providerId="LiveId" clId="{76C9B083-C5CE-54A4-81E8-16672380D724}" dt="2026-07-22T21:58:07.771" v="554"/>
+          <ac:picMkLst>
+            <pc:docMk/>
+            <pc:sldMk cId="3359188529" sldId="266"/>
+            <ac:picMk id="4" creationId="{42E316BF-0E33-D909-7ED5-918C0B3CBBEA}"/>
+          </ac:picMkLst>
+        </pc:picChg>
+      </pc:sldChg>
+      <pc:sldChg chg="addSp delSp modSp new mod">
+        <pc:chgData name="Lars Pettersson" userId="bbe8ee3e1743ce4e" providerId="LiveId" clId="{76C9B083-C5CE-54A4-81E8-16672380D724}" dt="2026-07-22T21:59:51.188" v="557"/>
+        <pc:sldMkLst>
+          <pc:docMk/>
+          <pc:sldMk cId="1458638347" sldId="267"/>
+        </pc:sldMkLst>
+        <pc:spChg chg="del">
+          <ac:chgData name="Lars Pettersson" userId="bbe8ee3e1743ce4e" providerId="LiveId" clId="{76C9B083-C5CE-54A4-81E8-16672380D724}" dt="2026-07-22T21:59:50.523" v="556" actId="478"/>
+          <ac:spMkLst>
+            <pc:docMk/>
+            <pc:sldMk cId="1458638347" sldId="267"/>
+            <ac:spMk id="2" creationId="{BA5C5117-B81D-46A9-88D1-B7C3C86284FC}"/>
+          </ac:spMkLst>
+        </pc:spChg>
+        <pc:spChg chg="del">
+          <ac:chgData name="Lars Pettersson" userId="bbe8ee3e1743ce4e" providerId="LiveId" clId="{76C9B083-C5CE-54A4-81E8-16672380D724}" dt="2026-07-22T21:59:50.523" v="556" actId="478"/>
+          <ac:spMkLst>
+            <pc:docMk/>
+            <pc:sldMk cId="1458638347" sldId="267"/>
+            <ac:spMk id="3" creationId="{F4315395-F81E-C2D9-6240-FF48EB7F36CC}"/>
+          </ac:spMkLst>
+        </pc:spChg>
+        <pc:picChg chg="add mod">
+          <ac:chgData name="Lars Pettersson" userId="bbe8ee3e1743ce4e" providerId="LiveId" clId="{76C9B083-C5CE-54A4-81E8-16672380D724}" dt="2026-07-22T21:59:51.188" v="557"/>
+          <ac:picMkLst>
+            <pc:docMk/>
+            <pc:sldMk cId="1458638347" sldId="267"/>
+            <ac:picMk id="4" creationId="{16015A6F-4D92-4DF2-9DAB-9E06607B59BE}"/>
+          </ac:picMkLst>
+        </pc:picChg>
+      </pc:sldChg>
+      <pc:sldChg chg="addSp delSp modSp new mod">
+        <pc:chgData name="Lars Pettersson" userId="bbe8ee3e1743ce4e" providerId="LiveId" clId="{76C9B083-C5CE-54A4-81E8-16672380D724}" dt="2026-07-22T22:12:15.667" v="565"/>
+        <pc:sldMkLst>
+          <pc:docMk/>
+          <pc:sldMk cId="2165640143" sldId="268"/>
+        </pc:sldMkLst>
+        <pc:spChg chg="del">
+          <ac:chgData name="Lars Pettersson" userId="bbe8ee3e1743ce4e" providerId="LiveId" clId="{76C9B083-C5CE-54A4-81E8-16672380D724}" dt="2026-07-22T22:10:42.697" v="559" actId="478"/>
+          <ac:spMkLst>
+            <pc:docMk/>
+            <pc:sldMk cId="2165640143" sldId="268"/>
+            <ac:spMk id="2" creationId="{6DCEF822-5E88-DD19-4EBB-7243DCDC58A1}"/>
+          </ac:spMkLst>
+        </pc:spChg>
+        <pc:spChg chg="del">
+          <ac:chgData name="Lars Pettersson" userId="bbe8ee3e1743ce4e" providerId="LiveId" clId="{76C9B083-C5CE-54A4-81E8-16672380D724}" dt="2026-07-22T22:10:42.697" v="559" actId="478"/>
+          <ac:spMkLst>
+            <pc:docMk/>
+            <pc:sldMk cId="2165640143" sldId="268"/>
+            <ac:spMk id="3" creationId="{C30DF9A6-3AEA-770E-FB11-B9D979C4B947}"/>
+          </ac:spMkLst>
+        </pc:spChg>
+        <pc:picChg chg="add mod">
+          <ac:chgData name="Lars Pettersson" userId="bbe8ee3e1743ce4e" providerId="LiveId" clId="{76C9B083-C5CE-54A4-81E8-16672380D724}" dt="2026-07-22T22:10:43.115" v="560"/>
+          <ac:picMkLst>
+            <pc:docMk/>
+            <pc:sldMk cId="2165640143" sldId="268"/>
+            <ac:picMk id="4" creationId="{9F9B0893-8F2C-D460-5B73-E92DB5AE045B}"/>
+          </ac:picMkLst>
+        </pc:picChg>
+        <pc:picChg chg="add">
+          <ac:chgData name="Lars Pettersson" userId="bbe8ee3e1743ce4e" providerId="LiveId" clId="{76C9B083-C5CE-54A4-81E8-16672380D724}" dt="2026-07-22T22:12:15.667" v="565"/>
+          <ac:picMkLst>
+            <pc:docMk/>
+            <pc:sldMk cId="2165640143" sldId="268"/>
+            <ac:picMk id="5" creationId="{6DC52F12-2FC7-AAAB-F693-FF2121DF445A}"/>
+          </ac:picMkLst>
+        </pc:picChg>
+      </pc:sldChg>
+      <pc:sldChg chg="addSp delSp modSp new mod ord">
+        <pc:chgData name="Lars Pettersson" userId="bbe8ee3e1743ce4e" providerId="LiveId" clId="{76C9B083-C5CE-54A4-81E8-16672380D724}" dt="2026-07-22T22:11:26.881" v="564" actId="20578"/>
+        <pc:sldMkLst>
+          <pc:docMk/>
+          <pc:sldMk cId="266269948" sldId="269"/>
+        </pc:sldMkLst>
+        <pc:spChg chg="del">
+          <ac:chgData name="Lars Pettersson" userId="bbe8ee3e1743ce4e" providerId="LiveId" clId="{76C9B083-C5CE-54A4-81E8-16672380D724}" dt="2026-07-22T22:11:22.377" v="562" actId="478"/>
+          <ac:spMkLst>
+            <pc:docMk/>
+            <pc:sldMk cId="266269948" sldId="269"/>
+            <ac:spMk id="2" creationId="{B48E2967-6FAD-80D9-29C1-9C70CBC10B39}"/>
+          </ac:spMkLst>
+        </pc:spChg>
+        <pc:spChg chg="del">
+          <ac:chgData name="Lars Pettersson" userId="bbe8ee3e1743ce4e" providerId="LiveId" clId="{76C9B083-C5CE-54A4-81E8-16672380D724}" dt="2026-07-22T22:11:22.377" v="562" actId="478"/>
+          <ac:spMkLst>
+            <pc:docMk/>
+            <pc:sldMk cId="266269948" sldId="269"/>
+            <ac:spMk id="3" creationId="{AA052D90-6155-3C67-6C72-0720BC471AA9}"/>
+          </ac:spMkLst>
+        </pc:spChg>
+        <pc:picChg chg="add mod">
+          <ac:chgData name="Lars Pettersson" userId="bbe8ee3e1743ce4e" providerId="LiveId" clId="{76C9B083-C5CE-54A4-81E8-16672380D724}" dt="2026-07-22T22:11:23.128" v="563"/>
+          <ac:picMkLst>
+            <pc:docMk/>
+            <pc:sldMk cId="266269948" sldId="269"/>
+            <ac:picMk id="4" creationId="{F5DB32A6-8EC6-4D87-5798-F1744FB5DF26}"/>
+          </ac:picMkLst>
+        </pc:picChg>
+      </pc:sldChg>
+      <pc:sldChg chg="addSp delSp new mod">
+        <pc:chgData name="Lars Pettersson" userId="bbe8ee3e1743ce4e" providerId="LiveId" clId="{76C9B083-C5CE-54A4-81E8-16672380D724}" dt="2026-07-22T22:12:23.226" v="568"/>
+        <pc:sldMkLst>
+          <pc:docMk/>
+          <pc:sldMk cId="1866145741" sldId="270"/>
+        </pc:sldMkLst>
+        <pc:spChg chg="del">
+          <ac:chgData name="Lars Pettersson" userId="bbe8ee3e1743ce4e" providerId="LiveId" clId="{76C9B083-C5CE-54A4-81E8-16672380D724}" dt="2026-07-22T22:12:21.438" v="567" actId="478"/>
+          <ac:spMkLst>
+            <pc:docMk/>
+            <pc:sldMk cId="1866145741" sldId="270"/>
+            <ac:spMk id="2" creationId="{B70BE380-3282-696D-9A2E-83131672256F}"/>
+          </ac:spMkLst>
+        </pc:spChg>
+        <pc:spChg chg="del">
+          <ac:chgData name="Lars Pettersson" userId="bbe8ee3e1743ce4e" providerId="LiveId" clId="{76C9B083-C5CE-54A4-81E8-16672380D724}" dt="2026-07-22T22:12:21.438" v="567" actId="478"/>
+          <ac:spMkLst>
+            <pc:docMk/>
+            <pc:sldMk cId="1866145741" sldId="270"/>
+            <ac:spMk id="3" creationId="{51F98190-98E5-2E66-62D9-DFD905A0FBB9}"/>
+          </ac:spMkLst>
+        </pc:spChg>
+        <pc:picChg chg="add">
+          <ac:chgData name="Lars Pettersson" userId="bbe8ee3e1743ce4e" providerId="LiveId" clId="{76C9B083-C5CE-54A4-81E8-16672380D724}" dt="2026-07-22T22:12:23.226" v="568"/>
+          <ac:picMkLst>
+            <pc:docMk/>
+            <pc:sldMk cId="1866145741" sldId="270"/>
+            <ac:picMk id="4" creationId="{E4A427EB-03A2-5111-1D91-F089701264C6}"/>
+          </ac:picMkLst>
+        </pc:picChg>
+      </pc:sldChg>
     </pc:docChg>
   </pc:docChgLst>
 </pc:chgInfo>
@@ -568,7 +800,7 @@
           <a:p>
             <a:fld id="{BF72FBC3-9AC7-554F-B508-118BD7145C7B}" type="datetimeFigureOut">
               <a:rPr lang="en-US" smtClean="0"/>
-              <a:t>7/21/26</a:t>
+              <a:t>7/22/26</a:t>
             </a:fld>
             <a:endParaRPr lang="en-US"/>
           </a:p>
@@ -766,7 +998,7 @@
           <a:p>
             <a:fld id="{BF72FBC3-9AC7-554F-B508-118BD7145C7B}" type="datetimeFigureOut">
               <a:rPr lang="en-US" smtClean="0"/>
-              <a:t>7/21/26</a:t>
+              <a:t>7/22/26</a:t>
             </a:fld>
             <a:endParaRPr lang="en-US"/>
           </a:p>
@@ -974,7 +1206,7 @@
           <a:p>
             <a:fld id="{BF72FBC3-9AC7-554F-B508-118BD7145C7B}" type="datetimeFigureOut">
               <a:rPr lang="en-US" smtClean="0"/>
-              <a:t>7/21/26</a:t>
+              <a:t>7/22/26</a:t>
             </a:fld>
             <a:endParaRPr lang="en-US"/>
           </a:p>
@@ -1172,7 +1404,7 @@
           <a:p>
             <a:fld id="{BF72FBC3-9AC7-554F-B508-118BD7145C7B}" type="datetimeFigureOut">
               <a:rPr lang="en-US" smtClean="0"/>
-              <a:t>7/21/26</a:t>
+              <a:t>7/22/26</a:t>
             </a:fld>
             <a:endParaRPr lang="en-US"/>
           </a:p>
@@ -1447,7 +1679,7 @@
           <a:p>
             <a:fld id="{BF72FBC3-9AC7-554F-B508-118BD7145C7B}" type="datetimeFigureOut">
               <a:rPr lang="en-US" smtClean="0"/>
-              <a:t>7/21/26</a:t>
+              <a:t>7/22/26</a:t>
             </a:fld>
             <a:endParaRPr lang="en-US"/>
           </a:p>
@@ -1712,7 +1944,7 @@
           <a:p>
             <a:fld id="{BF72FBC3-9AC7-554F-B508-118BD7145C7B}" type="datetimeFigureOut">
               <a:rPr lang="en-US" smtClean="0"/>
-              <a:t>7/21/26</a:t>
+              <a:t>7/22/26</a:t>
             </a:fld>
             <a:endParaRPr lang="en-US"/>
           </a:p>
@@ -2124,7 +2356,7 @@
           <a:p>
             <a:fld id="{BF72FBC3-9AC7-554F-B508-118BD7145C7B}" type="datetimeFigureOut">
               <a:rPr lang="en-US" smtClean="0"/>
-              <a:t>7/21/26</a:t>
+              <a:t>7/22/26</a:t>
             </a:fld>
             <a:endParaRPr lang="en-US"/>
           </a:p>
@@ -2265,7 +2497,7 @@
           <a:p>
             <a:fld id="{BF72FBC3-9AC7-554F-B508-118BD7145C7B}" type="datetimeFigureOut">
               <a:rPr lang="en-US" smtClean="0"/>
-              <a:t>7/21/26</a:t>
+              <a:t>7/22/26</a:t>
             </a:fld>
             <a:endParaRPr lang="en-US"/>
           </a:p>
@@ -2378,7 +2610,7 @@
           <a:p>
             <a:fld id="{BF72FBC3-9AC7-554F-B508-118BD7145C7B}" type="datetimeFigureOut">
               <a:rPr lang="en-US" smtClean="0"/>
-              <a:t>7/21/26</a:t>
+              <a:t>7/22/26</a:t>
             </a:fld>
             <a:endParaRPr lang="en-US"/>
           </a:p>
@@ -2689,7 +2921,7 @@
           <a:p>
             <a:fld id="{BF72FBC3-9AC7-554F-B508-118BD7145C7B}" type="datetimeFigureOut">
               <a:rPr lang="en-US" smtClean="0"/>
-              <a:t>7/21/26</a:t>
+              <a:t>7/22/26</a:t>
             </a:fld>
             <a:endParaRPr lang="en-US"/>
           </a:p>
@@ -2977,7 +3209,7 @@
           <a:p>
             <a:fld id="{BF72FBC3-9AC7-554F-B508-118BD7145C7B}" type="datetimeFigureOut">
               <a:rPr lang="en-US" smtClean="0"/>
-              <a:t>7/21/26</a:t>
+              <a:t>7/22/26</a:t>
             </a:fld>
             <a:endParaRPr lang="en-US"/>
           </a:p>
@@ -3218,7 +3450,7 @@
           <a:p>
             <a:fld id="{BF72FBC3-9AC7-554F-B508-118BD7145C7B}" type="datetimeFigureOut">
               <a:rPr lang="en-US" smtClean="0"/>
-              <a:t>7/21/26</a:t>
+              <a:t>7/22/26</a:t>
             </a:fld>
             <a:endParaRPr lang="en-US"/>
           </a:p>
@@ -3843,7 +4075,427 @@
 </p:sld>
 </file>
 
+<file path=ppt/slides/slide10.xml><?xml version="1.0" encoding="utf-8"?>
+<p:sld xmlns:a="http://schemas.openxmlformats.org/drawingml/2006/main" xmlns:r="http://schemas.openxmlformats.org/officeDocument/2006/relationships" xmlns:p="http://schemas.openxmlformats.org/presentationml/2006/main">
+  <p:cSld>
+    <p:spTree>
+      <p:nvGrpSpPr>
+        <p:cNvPr id="1" name=""/>
+        <p:cNvGrpSpPr/>
+        <p:nvPr/>
+      </p:nvGrpSpPr>
+      <p:grpSpPr>
+        <a:xfrm>
+          <a:off x="0" y="0"/>
+          <a:ext cx="0" cy="0"/>
+          <a:chOff x="0" y="0"/>
+          <a:chExt cx="0" cy="0"/>
+        </a:xfrm>
+      </p:grpSpPr>
+      <p:pic>
+        <p:nvPicPr>
+          <p:cNvPr id="4" name="Picture 3">
+            <a:extLst>
+              <a:ext uri="{FF2B5EF4-FFF2-40B4-BE49-F238E27FC236}">
+                <a16:creationId xmlns:a16="http://schemas.microsoft.com/office/drawing/2014/main" id="{00A3418D-F54E-9511-0CC1-626C987B9737}"/>
+              </a:ext>
+            </a:extLst>
+          </p:cNvPr>
+          <p:cNvPicPr>
+            <a:picLocks noChangeAspect="1"/>
+          </p:cNvPicPr>
+          <p:nvPr/>
+        </p:nvPicPr>
+        <p:blipFill>
+          <a:blip r:embed="rId2"/>
+          <a:stretch>
+            <a:fillRect/>
+          </a:stretch>
+        </p:blipFill>
+        <p:spPr>
+          <a:xfrm>
+            <a:off x="2209800" y="1757762"/>
+            <a:ext cx="7772400" cy="3342475"/>
+          </a:xfrm>
+          <a:prstGeom prst="rect">
+            <a:avLst/>
+          </a:prstGeom>
+        </p:spPr>
+      </p:pic>
+    </p:spTree>
+    <p:extLst>
+      <p:ext uri="{BB962C8B-B14F-4D97-AF65-F5344CB8AC3E}">
+        <p14:creationId xmlns:p14="http://schemas.microsoft.com/office/powerpoint/2010/main" val="1586328075"/>
+      </p:ext>
+    </p:extLst>
+  </p:cSld>
+  <p:clrMapOvr>
+    <a:masterClrMapping/>
+  </p:clrMapOvr>
+</p:sld>
+</file>
+
+<file path=ppt/slides/slide11.xml><?xml version="1.0" encoding="utf-8"?>
+<p:sld xmlns:a="http://schemas.openxmlformats.org/drawingml/2006/main" xmlns:r="http://schemas.openxmlformats.org/officeDocument/2006/relationships" xmlns:p="http://schemas.openxmlformats.org/presentationml/2006/main">
+  <p:cSld>
+    <p:spTree>
+      <p:nvGrpSpPr>
+        <p:cNvPr id="1" name=""/>
+        <p:cNvGrpSpPr/>
+        <p:nvPr/>
+      </p:nvGrpSpPr>
+      <p:grpSpPr>
+        <a:xfrm>
+          <a:off x="0" y="0"/>
+          <a:ext cx="0" cy="0"/>
+          <a:chOff x="0" y="0"/>
+          <a:chExt cx="0" cy="0"/>
+        </a:xfrm>
+      </p:grpSpPr>
+      <p:pic>
+        <p:nvPicPr>
+          <p:cNvPr id="4" name="Picture 3">
+            <a:extLst>
+              <a:ext uri="{FF2B5EF4-FFF2-40B4-BE49-F238E27FC236}">
+                <a16:creationId xmlns:a16="http://schemas.microsoft.com/office/drawing/2014/main" id="{42E316BF-0E33-D909-7ED5-918C0B3CBBEA}"/>
+              </a:ext>
+            </a:extLst>
+          </p:cNvPr>
+          <p:cNvPicPr>
+            <a:picLocks noChangeAspect="1"/>
+          </p:cNvPicPr>
+          <p:nvPr/>
+        </p:nvPicPr>
+        <p:blipFill>
+          <a:blip r:embed="rId2"/>
+          <a:stretch>
+            <a:fillRect/>
+          </a:stretch>
+        </p:blipFill>
+        <p:spPr>
+          <a:xfrm>
+            <a:off x="2479109" y="0"/>
+            <a:ext cx="7233781" cy="6858000"/>
+          </a:xfrm>
+          <a:prstGeom prst="rect">
+            <a:avLst/>
+          </a:prstGeom>
+        </p:spPr>
+      </p:pic>
+    </p:spTree>
+    <p:extLst>
+      <p:ext uri="{BB962C8B-B14F-4D97-AF65-F5344CB8AC3E}">
+        <p14:creationId xmlns:p14="http://schemas.microsoft.com/office/powerpoint/2010/main" val="3359188529"/>
+      </p:ext>
+    </p:extLst>
+  </p:cSld>
+  <p:clrMapOvr>
+    <a:masterClrMapping/>
+  </p:clrMapOvr>
+</p:sld>
+</file>
+
+<file path=ppt/slides/slide12.xml><?xml version="1.0" encoding="utf-8"?>
+<p:sld xmlns:a="http://schemas.openxmlformats.org/drawingml/2006/main" xmlns:r="http://schemas.openxmlformats.org/officeDocument/2006/relationships" xmlns:p="http://schemas.openxmlformats.org/presentationml/2006/main">
+  <p:cSld>
+    <p:spTree>
+      <p:nvGrpSpPr>
+        <p:cNvPr id="1" name=""/>
+        <p:cNvGrpSpPr/>
+        <p:nvPr/>
+      </p:nvGrpSpPr>
+      <p:grpSpPr>
+        <a:xfrm>
+          <a:off x="0" y="0"/>
+          <a:ext cx="0" cy="0"/>
+          <a:chOff x="0" y="0"/>
+          <a:chExt cx="0" cy="0"/>
+        </a:xfrm>
+      </p:grpSpPr>
+      <p:pic>
+        <p:nvPicPr>
+          <p:cNvPr id="4" name="Picture 3">
+            <a:extLst>
+              <a:ext uri="{FF2B5EF4-FFF2-40B4-BE49-F238E27FC236}">
+                <a16:creationId xmlns:a16="http://schemas.microsoft.com/office/drawing/2014/main" id="{16015A6F-4D92-4DF2-9DAB-9E06607B59BE}"/>
+              </a:ext>
+            </a:extLst>
+          </p:cNvPr>
+          <p:cNvPicPr>
+            <a:picLocks noChangeAspect="1"/>
+          </p:cNvPicPr>
+          <p:nvPr/>
+        </p:nvPicPr>
+        <p:blipFill>
+          <a:blip r:embed="rId2"/>
+          <a:stretch>
+            <a:fillRect/>
+          </a:stretch>
+        </p:blipFill>
+        <p:spPr>
+          <a:xfrm>
+            <a:off x="2209800" y="1987543"/>
+            <a:ext cx="7772400" cy="2882913"/>
+          </a:xfrm>
+          <a:prstGeom prst="rect">
+            <a:avLst/>
+          </a:prstGeom>
+        </p:spPr>
+      </p:pic>
+    </p:spTree>
+    <p:extLst>
+      <p:ext uri="{BB962C8B-B14F-4D97-AF65-F5344CB8AC3E}">
+        <p14:creationId xmlns:p14="http://schemas.microsoft.com/office/powerpoint/2010/main" val="1458638347"/>
+      </p:ext>
+    </p:extLst>
+  </p:cSld>
+  <p:clrMapOvr>
+    <a:masterClrMapping/>
+  </p:clrMapOvr>
+</p:sld>
+</file>
+
+<file path=ppt/slides/slide13.xml><?xml version="1.0" encoding="utf-8"?>
+<p:sld xmlns:a="http://schemas.openxmlformats.org/drawingml/2006/main" xmlns:r="http://schemas.openxmlformats.org/officeDocument/2006/relationships" xmlns:p="http://schemas.openxmlformats.org/presentationml/2006/main">
+  <p:cSld>
+    <p:spTree>
+      <p:nvGrpSpPr>
+        <p:cNvPr id="1" name=""/>
+        <p:cNvGrpSpPr/>
+        <p:nvPr/>
+      </p:nvGrpSpPr>
+      <p:grpSpPr>
+        <a:xfrm>
+          <a:off x="0" y="0"/>
+          <a:ext cx="0" cy="0"/>
+          <a:chOff x="0" y="0"/>
+          <a:chExt cx="0" cy="0"/>
+        </a:xfrm>
+      </p:grpSpPr>
+      <p:pic>
+        <p:nvPicPr>
+          <p:cNvPr id="4" name="Picture 3">
+            <a:extLst>
+              <a:ext uri="{FF2B5EF4-FFF2-40B4-BE49-F238E27FC236}">
+                <a16:creationId xmlns:a16="http://schemas.microsoft.com/office/drawing/2014/main" id="{F5DB32A6-8EC6-4D87-5798-F1744FB5DF26}"/>
+              </a:ext>
+            </a:extLst>
+          </p:cNvPr>
+          <p:cNvPicPr>
+            <a:picLocks noChangeAspect="1"/>
+          </p:cNvPicPr>
+          <p:nvPr/>
+        </p:nvPicPr>
+        <p:blipFill>
+          <a:blip r:embed="rId2"/>
+          <a:stretch>
+            <a:fillRect/>
+          </a:stretch>
+        </p:blipFill>
+        <p:spPr>
+          <a:xfrm>
+            <a:off x="2209800" y="313975"/>
+            <a:ext cx="7772400" cy="6230050"/>
+          </a:xfrm>
+          <a:prstGeom prst="rect">
+            <a:avLst/>
+          </a:prstGeom>
+        </p:spPr>
+      </p:pic>
+    </p:spTree>
+    <p:extLst>
+      <p:ext uri="{BB962C8B-B14F-4D97-AF65-F5344CB8AC3E}">
+        <p14:creationId xmlns:p14="http://schemas.microsoft.com/office/powerpoint/2010/main" val="266269948"/>
+      </p:ext>
+    </p:extLst>
+  </p:cSld>
+  <p:clrMapOvr>
+    <a:masterClrMapping/>
+  </p:clrMapOvr>
+</p:sld>
+</file>
+
+<file path=ppt/slides/slide14.xml><?xml version="1.0" encoding="utf-8"?>
+<p:sld xmlns:a="http://schemas.openxmlformats.org/drawingml/2006/main" xmlns:r="http://schemas.openxmlformats.org/officeDocument/2006/relationships" xmlns:p="http://schemas.openxmlformats.org/presentationml/2006/main">
+  <p:cSld>
+    <p:spTree>
+      <p:nvGrpSpPr>
+        <p:cNvPr id="1" name=""/>
+        <p:cNvGrpSpPr/>
+        <p:nvPr/>
+      </p:nvGrpSpPr>
+      <p:grpSpPr>
+        <a:xfrm>
+          <a:off x="0" y="0"/>
+          <a:ext cx="0" cy="0"/>
+          <a:chOff x="0" y="0"/>
+          <a:chExt cx="0" cy="0"/>
+        </a:xfrm>
+      </p:grpSpPr>
+      <p:pic>
+        <p:nvPicPr>
+          <p:cNvPr id="4" name="Picture 3">
+            <a:extLst>
+              <a:ext uri="{FF2B5EF4-FFF2-40B4-BE49-F238E27FC236}">
+                <a16:creationId xmlns:a16="http://schemas.microsoft.com/office/drawing/2014/main" id="{9F9B0893-8F2C-D460-5B73-E92DB5AE045B}"/>
+              </a:ext>
+            </a:extLst>
+          </p:cNvPr>
+          <p:cNvPicPr>
+            <a:picLocks noChangeAspect="1"/>
+          </p:cNvPicPr>
+          <p:nvPr/>
+        </p:nvPicPr>
+        <p:blipFill>
+          <a:blip r:embed="rId2"/>
+          <a:stretch>
+            <a:fillRect/>
+          </a:stretch>
+        </p:blipFill>
+        <p:spPr>
+          <a:xfrm>
+            <a:off x="2209800" y="911658"/>
+            <a:ext cx="7772400" cy="5034684"/>
+          </a:xfrm>
+          <a:prstGeom prst="rect">
+            <a:avLst/>
+          </a:prstGeom>
+        </p:spPr>
+      </p:pic>
+    </p:spTree>
+    <p:extLst>
+      <p:ext uri="{BB962C8B-B14F-4D97-AF65-F5344CB8AC3E}">
+        <p14:creationId xmlns:p14="http://schemas.microsoft.com/office/powerpoint/2010/main" val="2165640143"/>
+      </p:ext>
+    </p:extLst>
+  </p:cSld>
+  <p:clrMapOvr>
+    <a:masterClrMapping/>
+  </p:clrMapOvr>
+</p:sld>
+</file>
+
+<file path=ppt/slides/slide15.xml><?xml version="1.0" encoding="utf-8"?>
+<p:sld xmlns:a="http://schemas.openxmlformats.org/drawingml/2006/main" xmlns:r="http://schemas.openxmlformats.org/officeDocument/2006/relationships" xmlns:p="http://schemas.openxmlformats.org/presentationml/2006/main">
+  <p:cSld>
+    <p:spTree>
+      <p:nvGrpSpPr>
+        <p:cNvPr id="1" name=""/>
+        <p:cNvGrpSpPr/>
+        <p:nvPr/>
+      </p:nvGrpSpPr>
+      <p:grpSpPr>
+        <a:xfrm>
+          <a:off x="0" y="0"/>
+          <a:ext cx="0" cy="0"/>
+          <a:chOff x="0" y="0"/>
+          <a:chExt cx="0" cy="0"/>
+        </a:xfrm>
+      </p:grpSpPr>
+      <p:pic>
+        <p:nvPicPr>
+          <p:cNvPr id="4" name="Picture 3">
+            <a:extLst>
+              <a:ext uri="{FF2B5EF4-FFF2-40B4-BE49-F238E27FC236}">
+                <a16:creationId xmlns:a16="http://schemas.microsoft.com/office/drawing/2014/main" id="{E4A427EB-03A2-5111-1D91-F089701264C6}"/>
+              </a:ext>
+            </a:extLst>
+          </p:cNvPr>
+          <p:cNvPicPr>
+            <a:picLocks noChangeAspect="1"/>
+          </p:cNvPicPr>
+          <p:nvPr/>
+        </p:nvPicPr>
+        <p:blipFill>
+          <a:blip r:embed="rId2"/>
+          <a:stretch>
+            <a:fillRect/>
+          </a:stretch>
+        </p:blipFill>
+        <p:spPr>
+          <a:xfrm>
+            <a:off x="2553572" y="0"/>
+            <a:ext cx="7084855" cy="6858000"/>
+          </a:xfrm>
+          <a:prstGeom prst="rect">
+            <a:avLst/>
+          </a:prstGeom>
+        </p:spPr>
+      </p:pic>
+    </p:spTree>
+    <p:extLst>
+      <p:ext uri="{BB962C8B-B14F-4D97-AF65-F5344CB8AC3E}">
+        <p14:creationId xmlns:p14="http://schemas.microsoft.com/office/powerpoint/2010/main" val="1866145741"/>
+      </p:ext>
+    </p:extLst>
+  </p:cSld>
+  <p:clrMapOvr>
+    <a:masterClrMapping/>
+  </p:clrMapOvr>
+</p:sld>
+</file>
+
 <file path=ppt/slides/slide2.xml><?xml version="1.0" encoding="utf-8"?>
+<p:sld xmlns:a="http://schemas.openxmlformats.org/drawingml/2006/main" xmlns:r="http://schemas.openxmlformats.org/officeDocument/2006/relationships" xmlns:p="http://schemas.openxmlformats.org/presentationml/2006/main">
+  <p:cSld>
+    <p:spTree>
+      <p:nvGrpSpPr>
+        <p:cNvPr id="1" name=""/>
+        <p:cNvGrpSpPr/>
+        <p:nvPr/>
+      </p:nvGrpSpPr>
+      <p:grpSpPr>
+        <a:xfrm>
+          <a:off x="0" y="0"/>
+          <a:ext cx="0" cy="0"/>
+          <a:chOff x="0" y="0"/>
+          <a:chExt cx="0" cy="0"/>
+        </a:xfrm>
+      </p:grpSpPr>
+      <p:pic>
+        <p:nvPicPr>
+          <p:cNvPr id="4" name="Picture 3">
+            <a:extLst>
+              <a:ext uri="{FF2B5EF4-FFF2-40B4-BE49-F238E27FC236}">
+                <a16:creationId xmlns:a16="http://schemas.microsoft.com/office/drawing/2014/main" id="{8E8615E9-AF47-9ECC-16FC-8191BD9D1CE3}"/>
+              </a:ext>
+            </a:extLst>
+          </p:cNvPr>
+          <p:cNvPicPr>
+            <a:picLocks noChangeAspect="1"/>
+          </p:cNvPicPr>
+          <p:nvPr/>
+        </p:nvPicPr>
+        <p:blipFill>
+          <a:blip r:embed="rId2"/>
+          <a:stretch>
+            <a:fillRect/>
+          </a:stretch>
+        </p:blipFill>
+        <p:spPr>
+          <a:xfrm>
+            <a:off x="2209800" y="287265"/>
+            <a:ext cx="7772400" cy="6283470"/>
+          </a:xfrm>
+          <a:prstGeom prst="rect">
+            <a:avLst/>
+          </a:prstGeom>
+        </p:spPr>
+      </p:pic>
+    </p:spTree>
+    <p:extLst>
+      <p:ext uri="{BB962C8B-B14F-4D97-AF65-F5344CB8AC3E}">
+        <p14:creationId xmlns:p14="http://schemas.microsoft.com/office/powerpoint/2010/main" val="1650482976"/>
+      </p:ext>
+    </p:extLst>
+  </p:cSld>
+  <p:clrMapOvr>
+    <a:masterClrMapping/>
+  </p:clrMapOvr>
+</p:sld>
+</file>
+
+<file path=ppt/slides/slide3.xml><?xml version="1.0" encoding="utf-8"?>
 <p:sld xmlns:a="http://schemas.openxmlformats.org/drawingml/2006/main" xmlns:r="http://schemas.openxmlformats.org/officeDocument/2006/relationships" xmlns:p="http://schemas.openxmlformats.org/presentationml/2006/main">
   <p:cSld>
     <p:spTree>
@@ -3953,7 +4605,7 @@
 </p:sld>
 </file>
 
-<file path=ppt/slides/slide3.xml><?xml version="1.0" encoding="utf-8"?>
+<file path=ppt/slides/slide4.xml><?xml version="1.0" encoding="utf-8"?>
 <p:sld xmlns:a="http://schemas.openxmlformats.org/drawingml/2006/main" xmlns:r="http://schemas.openxmlformats.org/officeDocument/2006/relationships" xmlns:p="http://schemas.openxmlformats.org/presentationml/2006/main">
   <p:cSld>
     <p:spTree>
@@ -4041,7 +4693,7 @@
 </p:sld>
 </file>
 
-<file path=ppt/slides/slide4.xml><?xml version="1.0" encoding="utf-8"?>
+<file path=ppt/slides/slide5.xml><?xml version="1.0" encoding="utf-8"?>
 <p:sld xmlns:a="http://schemas.openxmlformats.org/drawingml/2006/main" xmlns:r="http://schemas.openxmlformats.org/officeDocument/2006/relationships" xmlns:p="http://schemas.openxmlformats.org/presentationml/2006/main">
   <p:cSld>
     <p:spTree>
@@ -4131,7 +4783,7 @@
 </p:sld>
 </file>
 
-<file path=ppt/slides/slide5.xml><?xml version="1.0" encoding="utf-8"?>
+<file path=ppt/slides/slide6.xml><?xml version="1.0" encoding="utf-8"?>
 <p:sld xmlns:a="http://schemas.openxmlformats.org/drawingml/2006/main" xmlns:r="http://schemas.openxmlformats.org/officeDocument/2006/relationships" xmlns:p="http://schemas.openxmlformats.org/presentationml/2006/main">
   <p:cSld>
     <p:spTree>
@@ -4222,7 +4874,7 @@
 </p:sld>
 </file>
 
-<file path=ppt/slides/slide6.xml><?xml version="1.0" encoding="utf-8"?>
+<file path=ppt/slides/slide7.xml><?xml version="1.0" encoding="utf-8"?>
 <p:sld xmlns:a="http://schemas.openxmlformats.org/drawingml/2006/main" xmlns:r="http://schemas.openxmlformats.org/officeDocument/2006/relationships" xmlns:p="http://schemas.openxmlformats.org/presentationml/2006/main">
   <p:cSld>
     <p:spTree>
@@ -4372,7 +5024,7 @@
 </p:sld>
 </file>
 
-<file path=ppt/slides/slide7.xml><?xml version="1.0" encoding="utf-8"?>
+<file path=ppt/slides/slide8.xml><?xml version="1.0" encoding="utf-8"?>
 <p:sld xmlns:a="http://schemas.openxmlformats.org/drawingml/2006/main" xmlns:r="http://schemas.openxmlformats.org/officeDocument/2006/relationships" xmlns:p="http://schemas.openxmlformats.org/presentationml/2006/main">
   <p:cSld>
     <p:spTree>
@@ -4578,7 +5230,7 @@
 </p:sld>
 </file>
 
-<file path=ppt/slides/slide8.xml><?xml version="1.0" encoding="utf-8"?>
+<file path=ppt/slides/slide9.xml><?xml version="1.0" encoding="utf-8"?>
 <p:sld xmlns:a="http://schemas.openxmlformats.org/drawingml/2006/main" xmlns:r="http://schemas.openxmlformats.org/officeDocument/2006/relationships" xmlns:p="http://schemas.openxmlformats.org/presentationml/2006/main">
   <p:cSld>
     <p:spTree>

</xml_diff>

<commit_message>
Update Bowtie design notes deck.
Co-Authored-By: Claude Opus 5 (1M context) <noreply@anthropic.com>
</commit_message>
<xml_diff>
--- a/bowtie_design_notes.pptx
+++ b/bowtie_design_notes.pptx
@@ -129,7 +129,7 @@
 <file path=ppt/revisionInfo.xml><?xml version="1.0" encoding="utf-8"?>
 <p1510:revInfo xmlns:a="http://schemas.openxmlformats.org/drawingml/2006/main" xmlns:r="http://schemas.openxmlformats.org/officeDocument/2006/relationships" xmlns:p1510="http://schemas.microsoft.com/office/powerpoint/2015/10/main">
   <p1510:revLst>
-    <p1510:client id="{3BCA02BA-0FB2-DA4B-8BBC-CE8B401E8468}" v="24" dt="2026-07-22T22:12:23.226"/>
+    <p1510:client id="{3BCA02BA-0FB2-DA4B-8BBC-CE8B401E8468}" v="25" dt="2026-07-22T22:30:20.709"/>
   </p1510:revLst>
 </p1510:revInfo>
 </file>
@@ -139,7 +139,7 @@
   <pc:docChgLst>
     <pc:chgData name="Lars Pettersson" userId="bbe8ee3e1743ce4e" providerId="LiveId" clId="{76C9B083-C5CE-54A4-81E8-16672380D724}"/>
     <pc:docChg chg="undo custSel addSld modSld sldOrd">
-      <pc:chgData name="Lars Pettersson" userId="bbe8ee3e1743ce4e" providerId="LiveId" clId="{76C9B083-C5CE-54A4-81E8-16672380D724}" dt="2026-07-22T22:12:23.226" v="568"/>
+      <pc:chgData name="Lars Pettersson" userId="bbe8ee3e1743ce4e" providerId="LiveId" clId="{76C9B083-C5CE-54A4-81E8-16672380D724}" dt="2026-07-22T22:30:34.399" v="573" actId="1076"/>
       <pc:docMkLst>
         <pc:docMk/>
       </pc:docMkLst>
@@ -617,8 +617,8 @@
           </ac:picMkLst>
         </pc:picChg>
       </pc:sldChg>
-      <pc:sldChg chg="addSp delSp new mod">
-        <pc:chgData name="Lars Pettersson" userId="bbe8ee3e1743ce4e" providerId="LiveId" clId="{76C9B083-C5CE-54A4-81E8-16672380D724}" dt="2026-07-22T22:12:23.226" v="568"/>
+      <pc:sldChg chg="addSp delSp modSp new mod">
+        <pc:chgData name="Lars Pettersson" userId="bbe8ee3e1743ce4e" providerId="LiveId" clId="{76C9B083-C5CE-54A4-81E8-16672380D724}" dt="2026-07-22T22:30:34.399" v="573" actId="1076"/>
         <pc:sldMkLst>
           <pc:docMk/>
           <pc:sldMk cId="1866145741" sldId="270"/>
@@ -629,6 +629,14 @@
             <pc:docMk/>
             <pc:sldMk cId="1866145741" sldId="270"/>
             <ac:spMk id="2" creationId="{B70BE380-3282-696D-9A2E-83131672256F}"/>
+          </ac:spMkLst>
+        </pc:spChg>
+        <pc:spChg chg="add mod">
+          <ac:chgData name="Lars Pettersson" userId="bbe8ee3e1743ce4e" providerId="LiveId" clId="{76C9B083-C5CE-54A4-81E8-16672380D724}" dt="2026-07-22T22:30:34.399" v="573" actId="1076"/>
+          <ac:spMkLst>
+            <pc:docMk/>
+            <pc:sldMk cId="1866145741" sldId="270"/>
+            <ac:spMk id="3" creationId="{1D0F1AC3-249D-012D-134B-E2FB0EFAF5DC}"/>
           </ac:spMkLst>
         </pc:spChg>
         <pc:spChg chg="del">
@@ -800,7 +808,7 @@
           <a:p>
             <a:fld id="{BF72FBC3-9AC7-554F-B508-118BD7145C7B}" type="datetimeFigureOut">
               <a:rPr lang="en-US" smtClean="0"/>
-              <a:t>7/22/26</a:t>
+              <a:t>7/23/26</a:t>
             </a:fld>
             <a:endParaRPr lang="en-US"/>
           </a:p>
@@ -998,7 +1006,7 @@
           <a:p>
             <a:fld id="{BF72FBC3-9AC7-554F-B508-118BD7145C7B}" type="datetimeFigureOut">
               <a:rPr lang="en-US" smtClean="0"/>
-              <a:t>7/22/26</a:t>
+              <a:t>7/23/26</a:t>
             </a:fld>
             <a:endParaRPr lang="en-US"/>
           </a:p>
@@ -1206,7 +1214,7 @@
           <a:p>
             <a:fld id="{BF72FBC3-9AC7-554F-B508-118BD7145C7B}" type="datetimeFigureOut">
               <a:rPr lang="en-US" smtClean="0"/>
-              <a:t>7/22/26</a:t>
+              <a:t>7/23/26</a:t>
             </a:fld>
             <a:endParaRPr lang="en-US"/>
           </a:p>
@@ -1404,7 +1412,7 @@
           <a:p>
             <a:fld id="{BF72FBC3-9AC7-554F-B508-118BD7145C7B}" type="datetimeFigureOut">
               <a:rPr lang="en-US" smtClean="0"/>
-              <a:t>7/22/26</a:t>
+              <a:t>7/23/26</a:t>
             </a:fld>
             <a:endParaRPr lang="en-US"/>
           </a:p>
@@ -1679,7 +1687,7 @@
           <a:p>
             <a:fld id="{BF72FBC3-9AC7-554F-B508-118BD7145C7B}" type="datetimeFigureOut">
               <a:rPr lang="en-US" smtClean="0"/>
-              <a:t>7/22/26</a:t>
+              <a:t>7/23/26</a:t>
             </a:fld>
             <a:endParaRPr lang="en-US"/>
           </a:p>
@@ -1944,7 +1952,7 @@
           <a:p>
             <a:fld id="{BF72FBC3-9AC7-554F-B508-118BD7145C7B}" type="datetimeFigureOut">
               <a:rPr lang="en-US" smtClean="0"/>
-              <a:t>7/22/26</a:t>
+              <a:t>7/23/26</a:t>
             </a:fld>
             <a:endParaRPr lang="en-US"/>
           </a:p>
@@ -2356,7 +2364,7 @@
           <a:p>
             <a:fld id="{BF72FBC3-9AC7-554F-B508-118BD7145C7B}" type="datetimeFigureOut">
               <a:rPr lang="en-US" smtClean="0"/>
-              <a:t>7/22/26</a:t>
+              <a:t>7/23/26</a:t>
             </a:fld>
             <a:endParaRPr lang="en-US"/>
           </a:p>
@@ -2497,7 +2505,7 @@
           <a:p>
             <a:fld id="{BF72FBC3-9AC7-554F-B508-118BD7145C7B}" type="datetimeFigureOut">
               <a:rPr lang="en-US" smtClean="0"/>
-              <a:t>7/22/26</a:t>
+              <a:t>7/23/26</a:t>
             </a:fld>
             <a:endParaRPr lang="en-US"/>
           </a:p>
@@ -2610,7 +2618,7 @@
           <a:p>
             <a:fld id="{BF72FBC3-9AC7-554F-B508-118BD7145C7B}" type="datetimeFigureOut">
               <a:rPr lang="en-US" smtClean="0"/>
-              <a:t>7/22/26</a:t>
+              <a:t>7/23/26</a:t>
             </a:fld>
             <a:endParaRPr lang="en-US"/>
           </a:p>
@@ -2921,7 +2929,7 @@
           <a:p>
             <a:fld id="{BF72FBC3-9AC7-554F-B508-118BD7145C7B}" type="datetimeFigureOut">
               <a:rPr lang="en-US" smtClean="0"/>
-              <a:t>7/22/26</a:t>
+              <a:t>7/23/26</a:t>
             </a:fld>
             <a:endParaRPr lang="en-US"/>
           </a:p>
@@ -3209,7 +3217,7 @@
           <a:p>
             <a:fld id="{BF72FBC3-9AC7-554F-B508-118BD7145C7B}" type="datetimeFigureOut">
               <a:rPr lang="en-US" smtClean="0"/>
-              <a:t>7/22/26</a:t>
+              <a:t>7/23/26</a:t>
             </a:fld>
             <a:endParaRPr lang="en-US"/>
           </a:p>
@@ -3450,7 +3458,7 @@
           <a:p>
             <a:fld id="{BF72FBC3-9AC7-554F-B508-118BD7145C7B}" type="datetimeFigureOut">
               <a:rPr lang="en-US" smtClean="0"/>
-              <a:t>7/22/26</a:t>
+              <a:t>7/23/26</a:t>
             </a:fld>
             <a:endParaRPr lang="en-US"/>
           </a:p>
@@ -4422,6 +4430,47 @@
           </a:prstGeom>
         </p:spPr>
       </p:pic>
+      <p:sp>
+        <p:nvSpPr>
+          <p:cNvPr id="3" name="TextBox 2">
+            <a:extLst>
+              <a:ext uri="{FF2B5EF4-FFF2-40B4-BE49-F238E27FC236}">
+                <a16:creationId xmlns:a16="http://schemas.microsoft.com/office/drawing/2014/main" id="{1D0F1AC3-249D-012D-134B-E2FB0EFAF5DC}"/>
+              </a:ext>
+            </a:extLst>
+          </p:cNvPr>
+          <p:cNvSpPr txBox="1"/>
+          <p:nvPr/>
+        </p:nvSpPr>
+        <p:spPr>
+          <a:xfrm>
+            <a:off x="265814" y="490501"/>
+            <a:ext cx="1913860" cy="923330"/>
+          </a:xfrm>
+          <a:prstGeom prst="rect">
+            <a:avLst/>
+          </a:prstGeom>
+          <a:noFill/>
+        </p:spPr>
+        <p:txBody>
+          <a:bodyPr wrap="square">
+            <a:spAutoFit/>
+          </a:bodyPr>
+          <a:lstStyle/>
+          <a:p>
+            <a:r>
+              <a:rPr lang="en-US" dirty="0">
+                <a:hlinkClick r:id="rId3"/>
+              </a:rPr>
+              <a:t>https://share.gemini.google/ktbD2LmdtH08</a:t>
+            </a:r>
+            <a:r>
+              <a:rPr lang="en-US" dirty="0"/>
+              <a:t> </a:t>
+            </a:r>
+          </a:p>
+        </p:txBody>
+      </p:sp>
     </p:spTree>
     <p:extLst>
       <p:ext uri="{BB962C8B-B14F-4D97-AF65-F5344CB8AC3E}">

</xml_diff>